<commit_message>
Update GroundTruth PowerPoint presentation to feature verbatim original input ingestion alongside output flowcharts for all 4 examples
</commit_message>
<xml_diff>
--- a/Capturing_World_Invariants_Ground_Truth.pptx
+++ b/Capturing_World_Invariants_Ground_Truth.pptx
@@ -12,6 +12,11 @@
     <p:sldId id="260" r:id="rId11"/>
     <p:sldId id="261" r:id="rId12"/>
     <p:sldId id="262" r:id="rId13"/>
+    <p:sldId id="263" r:id="rId14"/>
+    <p:sldId id="264" r:id="rId15"/>
+    <p:sldId id="265" r:id="rId16"/>
+    <p:sldId id="266" r:id="rId17"/>
+    <p:sldId id="267" r:id="rId18"/>
   </p:sldIdLst>
   <p:sldSz cx="12191695" cy="6858000" type="screen4x3"/>
   <p:notesSz cx="6858000" cy="9144000"/>
@@ -3110,8 +3115,8 @@
         </p:nvSpPr>
         <p:spPr>
           <a:xfrm>
-            <a:off x="731520" y="914400"/>
-            <a:ext cx="10728655" cy="5029200"/>
+            <a:off x="731520" y="822960"/>
+            <a:ext cx="10728655" cy="5212080"/>
           </a:xfrm>
           <a:prstGeom prst="roundRect">
             <a:avLst/>
@@ -3156,7 +3161,7 @@
           </a:p>
           <a:p>
             <a:pPr algn="ctr">
-              <a:defRPr sz="3800" b="1">
+              <a:defRPr sz="3600" b="1">
                 <a:solidFill>
                   <a:srgbClr val="0F172A"/>
                 </a:solidFill>
@@ -3168,7 +3173,7 @@
           </a:p>
           <a:p>
             <a:pPr algn="ctr">
-              <a:defRPr sz="3400" b="1">
+              <a:defRPr sz="3200" b="1">
                 <a:solidFill>
                   <a:srgbClr val="0284C7"/>
                 </a:solidFill>
@@ -3181,7 +3186,7 @@
           <a:p>
             <a:br/>
             <a:pPr algn="ctr">
-              <a:defRPr sz="1500">
+              <a:defRPr sz="1450">
                 <a:solidFill>
                   <a:srgbClr val="64748B"/>
                 </a:solidFill>
@@ -3194,14 +3199,803 @@
           <a:p>
             <a:br/>
             <a:pPr algn="ctr">
-              <a:defRPr sz="1200" b="1">
+              <a:defRPr sz="1150" b="1">
                 <a:solidFill>
                   <a:srgbClr val="475569"/>
                 </a:solidFill>
               </a:defRPr>
             </a:pPr>
             <a:r>
-              <a:t>4 Real-World Case Studies: Enterprise Security • FinTech AML • Cloud DevOps • Narrative Literature</a:t>
+              <a:t>Full Pipeline Walkthrough: Original Input Ingestion (Step 1) ➔ Ground Truth Compilation ➔ Flowchart DAGs (Step 2)</a:t>
+            </a:r>
+            <a:br/>
+            <a:r>
+              <a:t>Enterprise IT Security • FinTech AML • Cloud DevOps • Narrative Literature</a:t>
+            </a:r>
+          </a:p>
+        </p:txBody>
+      </p:sp>
+    </p:spTree>
+  </p:cSld>
+  <p:clrMapOvr>
+    <a:masterClrMapping/>
+  </p:clrMapOvr>
+</p:sld>
+</file>
+
+<file path=ppt/slides/slide10.xml><?xml version="1.0" encoding="utf-8"?>
+<p:sld xmlns:a="http://schemas.openxmlformats.org/drawingml/2006/main" xmlns:p="http://schemas.openxmlformats.org/presentationml/2006/main" xmlns:r="http://schemas.openxmlformats.org/officeDocument/2006/relationships">
+  <p:cSld>
+    <p:bg>
+      <p:bgPr>
+        <a:solidFill>
+          <a:srgbClr val="FFFFFF"/>
+        </a:solidFill>
+        <a:effectLst/>
+      </p:bgPr>
+    </p:bg>
+    <p:spTree>
+      <p:nvGrpSpPr>
+        <p:cNvPr id="1" name=""/>
+        <p:cNvGrpSpPr/>
+        <p:nvPr/>
+      </p:nvGrpSpPr>
+      <p:grpSpPr/>
+      <p:sp>
+        <p:nvSpPr>
+          <p:cNvPr id="2" name="TextBox 1"/>
+          <p:cNvSpPr txBox="1"/>
+          <p:nvPr/>
+        </p:nvSpPr>
+        <p:spPr>
+          <a:xfrm>
+            <a:off x="731520" y="320040"/>
+            <a:ext cx="7315200" cy="292608"/>
+          </a:xfrm>
+          <a:prstGeom prst="rect">
+            <a:avLst/>
+          </a:prstGeom>
+          <a:noFill/>
+        </p:spPr>
+        <p:txBody>
+          <a:bodyPr wrap="square">
+            <a:spAutoFit/>
+          </a:bodyPr>
+          <a:lstStyle/>
+          <a:p>
+            <a:pPr>
+              <a:defRPr sz="1000" b="1">
+                <a:solidFill>
+                  <a:srgbClr val="0284C7"/>
+                </a:solidFill>
+              </a:defRPr>
+            </a:pPr>
+            <a:r>
+              <a:t>📘 EXAMPLE 04 (PART 1): NARRATIVE PHYSICS &amp; FOLKLORE MODELING — ORIGINAL INPUT INTAKE</a:t>
+            </a:r>
+          </a:p>
+        </p:txBody>
+      </p:sp>
+      <p:sp>
+        <p:nvSpPr>
+          <p:cNvPr id="3" name="TextBox 2"/>
+          <p:cNvSpPr txBox="1"/>
+          <p:nvPr/>
+        </p:nvSpPr>
+        <p:spPr>
+          <a:xfrm>
+            <a:off x="731520" y="594360"/>
+            <a:ext cx="10515600" cy="502920"/>
+          </a:xfrm>
+          <a:prstGeom prst="rect">
+            <a:avLst/>
+          </a:prstGeom>
+          <a:noFill/>
+        </p:spPr>
+        <p:txBody>
+          <a:bodyPr wrap="square">
+            <a:spAutoFit/>
+          </a:bodyPr>
+          <a:lstStyle/>
+          <a:p>
+            <a:pPr>
+              <a:defRPr sz="2100" b="1">
+                <a:solidFill>
+                  <a:srgbClr val="0F172A"/>
+                </a:solidFill>
+              </a:defRPr>
+            </a:pPr>
+            <a:r>
+              <a:t>Literature: Original Novel Excerpt &amp; Web Intake</a:t>
+            </a:r>
+          </a:p>
+        </p:txBody>
+      </p:sp>
+      <p:sp>
+        <p:nvSpPr>
+          <p:cNvPr id="4" name="Rounded Rectangle 3"/>
+          <p:cNvSpPr/>
+          <p:nvPr/>
+        </p:nvSpPr>
+        <p:spPr>
+          <a:xfrm>
+            <a:off x="731520" y="1371600"/>
+            <a:ext cx="4754880" cy="5029200"/>
+          </a:xfrm>
+          <a:prstGeom prst="roundRect">
+            <a:avLst/>
+          </a:prstGeom>
+          <a:solidFill>
+            <a:srgbClr val="F8FAFC"/>
+          </a:solidFill>
+          <a:ln w="19050">
+            <a:solidFill>
+              <a:srgbClr val="E2E8F0"/>
+            </a:solidFill>
+          </a:ln>
+        </p:spPr>
+        <p:style>
+          <a:lnRef idx="1">
+            <a:schemeClr val="accent1"/>
+          </a:lnRef>
+          <a:fillRef idx="3">
+            <a:schemeClr val="accent1"/>
+          </a:fillRef>
+          <a:effectRef idx="2">
+            <a:schemeClr val="accent1"/>
+          </a:effectRef>
+          <a:fontRef idx="minor">
+            <a:schemeClr val="lt1"/>
+          </a:fontRef>
+        </p:style>
+        <p:txBody>
+          <a:bodyPr rtlCol="0" anchor="ctr" wrap="square"/>
+          <a:lstStyle/>
+          <a:p>
+            <a:pPr algn="ctr">
+              <a:defRPr sz="1050" b="1">
+                <a:solidFill>
+                  <a:srgbClr val="8B5CF6"/>
+                </a:solidFill>
+              </a:defRPr>
+            </a:pPr>
+            <a:r>
+              <a:t>📥 INPUT 1: RAW SOURCE DOCUMENT / SOP</a:t>
+            </a:r>
+          </a:p>
+          <a:p>
+            <a:pPr>
+              <a:defRPr sz="950" b="1">
+                <a:solidFill>
+                  <a:srgbClr val="0F172A"/>
+                </a:solidFill>
+              </a:defRPr>
+            </a:pPr>
+            <a:r>
+              <a:t>Title: Where Mountain Meets Moon Wbna33436633 (TODAY.com Excerpt)</a:t>
+            </a:r>
+          </a:p>
+          <a:p>
+            <a:pPr>
+              <a:defRPr sz="900" i="1">
+                <a:solidFill>
+                  <a:srgbClr val="334155"/>
+                </a:solidFill>
+              </a:defRPr>
+            </a:pPr>
+            <a:r>
+              <a:t>"Far away from here, following the Jade River, there was once a black mountain that cut into the sky like a jagged piece of rough metal. The villagers called it Fruitless Mountain because nothing grew on it and birds and animals did not rest there.</a:t>
+            </a:r>
+            <a:br/>
+            <a:r>
+              <a:t>Crowded in the corner of where Fruitless Mountain and the Jade River met was a village that was a shade of faded brown... One of the houses in this village was so small that its wood boards, held together by the roof, made one think of a bunch of matches tied with a piece of twine. Inside, there was barely enough room for three people to sit around the table — which was lucky because only three people lived there. One of them was a young girl called Minli.</a:t>
+            </a:r>
+            <a:br/>
+            <a:r>
+              <a:t>Minli was not brown and dull like the rest of the village. She had glossy black hair with pink cheeks, shining eyes always eager for adventure, and a fast smile... habit of quick acting."</a:t>
+            </a:r>
+          </a:p>
+          <a:p>
+            <a:br/>
+            <a:pPr>
+              <a:defRPr sz="1050" b="1">
+                <a:solidFill>
+                  <a:srgbClr val="0284C7"/>
+                </a:solidFill>
+              </a:defRPr>
+            </a:pPr>
+            <a:r>
+              <a:t>🌐 INPUT 2: WEB ADDRESS / TARGET ENDPOINT</a:t>
+            </a:r>
+          </a:p>
+          <a:p>
+            <a:pPr>
+              <a:defRPr sz="950" b="1">
+                <a:solidFill>
+                  <a:srgbClr val="0F172A"/>
+                </a:solidFill>
+              </a:defRPr>
+            </a:pPr>
+            <a:r>
+              <a:t>URL: https://www.today.com/popculture/where-mountain-meets-moon-wbna33436633</a:t>
+            </a:r>
+          </a:p>
+          <a:p>
+            <a:br/>
+            <a:pPr>
+              <a:defRPr sz="1050" b="1">
+                <a:solidFill>
+                  <a:srgbClr val="EF4444"/>
+                </a:solidFill>
+              </a:defRPr>
+            </a:pPr>
+            <a:r>
+              <a:t>⚠️ WHY NAIVE LLMS FAIL ON THIS INPUT</a:t>
+            </a:r>
+          </a:p>
+          <a:p>
+            <a:pPr>
+              <a:defRPr sz="919">
+                <a:solidFill>
+                  <a:srgbClr val="0F172A"/>
+                </a:solidFill>
+              </a:defRPr>
+            </a:pPr>
+            <a:r>
+              <a:t>Standard AI toolchains blindly force corporate telemetry boilerplate ('Enforce cryptographic SSO token interface') onto children's folklore! Ground truth requires adapting to the domain's real 'physics': barren terrain, poverty constraints, and the protagonist's impulsive nature.</a:t>
+            </a:r>
+          </a:p>
+        </p:txBody>
+      </p:sp>
+      <p:pic>
+        <p:nvPicPr>
+          <p:cNvPr id="5" name="Picture 4" descr="verified_today_com_step1.png"/>
+          <p:cNvPicPr>
+            <a:picLocks noChangeAspect="1"/>
+          </p:cNvPicPr>
+          <p:nvPr/>
+        </p:nvPicPr>
+        <p:blipFill>
+          <a:blip r:embed="rId2"/>
+          <a:stretch>
+            <a:fillRect/>
+          </a:stretch>
+        </p:blipFill>
+        <p:spPr>
+          <a:xfrm>
+            <a:off x="5669280" y="1371600"/>
+            <a:ext cx="5788152" cy="5029200"/>
+          </a:xfrm>
+          <a:prstGeom prst="rect">
+            <a:avLst/>
+          </a:prstGeom>
+        </p:spPr>
+      </p:pic>
+    </p:spTree>
+  </p:cSld>
+  <p:clrMapOvr>
+    <a:masterClrMapping/>
+  </p:clrMapOvr>
+</p:sld>
+</file>
+
+<file path=ppt/slides/slide11.xml><?xml version="1.0" encoding="utf-8"?>
+<p:sld xmlns:a="http://schemas.openxmlformats.org/drawingml/2006/main" xmlns:p="http://schemas.openxmlformats.org/presentationml/2006/main" xmlns:r="http://schemas.openxmlformats.org/officeDocument/2006/relationships">
+  <p:cSld>
+    <p:bg>
+      <p:bgPr>
+        <a:solidFill>
+          <a:srgbClr val="FFFFFF"/>
+        </a:solidFill>
+        <a:effectLst/>
+      </p:bgPr>
+    </p:bg>
+    <p:spTree>
+      <p:nvGrpSpPr>
+        <p:cNvPr id="1" name=""/>
+        <p:cNvGrpSpPr/>
+        <p:nvPr/>
+      </p:nvGrpSpPr>
+      <p:grpSpPr/>
+      <p:sp>
+        <p:nvSpPr>
+          <p:cNvPr id="2" name="TextBox 1"/>
+          <p:cNvSpPr txBox="1"/>
+          <p:nvPr/>
+        </p:nvSpPr>
+        <p:spPr>
+          <a:xfrm>
+            <a:off x="731520" y="320040"/>
+            <a:ext cx="7315200" cy="292608"/>
+          </a:xfrm>
+          <a:prstGeom prst="rect">
+            <a:avLst/>
+          </a:prstGeom>
+          <a:noFill/>
+        </p:spPr>
+        <p:txBody>
+          <a:bodyPr wrap="square">
+            <a:spAutoFit/>
+          </a:bodyPr>
+          <a:lstStyle/>
+          <a:p>
+            <a:pPr>
+              <a:defRPr sz="1000" b="1">
+                <a:solidFill>
+                  <a:srgbClr val="0284C7"/>
+                </a:solidFill>
+              </a:defRPr>
+            </a:pPr>
+            <a:r>
+              <a:t>📘 EXAMPLE 04 (PART 2): NARRATIVE PHYSICS &amp; FOLKLORE MODELING — GROUND TRUTH OUTPUT &amp; DAG</a:t>
+            </a:r>
+          </a:p>
+        </p:txBody>
+      </p:sp>
+      <p:sp>
+        <p:nvSpPr>
+          <p:cNvPr id="3" name="TextBox 2"/>
+          <p:cNvSpPr txBox="1"/>
+          <p:nvPr/>
+        </p:nvSpPr>
+        <p:spPr>
+          <a:xfrm>
+            <a:off x="731520" y="594360"/>
+            <a:ext cx="10515600" cy="502920"/>
+          </a:xfrm>
+          <a:prstGeom prst="rect">
+            <a:avLst/>
+          </a:prstGeom>
+          <a:noFill/>
+        </p:spPr>
+        <p:txBody>
+          <a:bodyPr wrap="square">
+            <a:spAutoFit/>
+          </a:bodyPr>
+          <a:lstStyle/>
+          <a:p>
+            <a:pPr>
+              <a:defRPr sz="2100" b="1">
+                <a:solidFill>
+                  <a:srgbClr val="0F172A"/>
+                </a:solidFill>
+              </a:defRPr>
+            </a:pPr>
+            <a:r>
+              <a:t>Literature: Narrative Physics &amp; Hero's Journey DAG</a:t>
+            </a:r>
+          </a:p>
+        </p:txBody>
+      </p:sp>
+      <p:sp>
+        <p:nvSpPr>
+          <p:cNvPr id="4" name="Rounded Rectangle 3"/>
+          <p:cNvSpPr/>
+          <p:nvPr/>
+        </p:nvSpPr>
+        <p:spPr>
+          <a:xfrm>
+            <a:off x="731520" y="1371600"/>
+            <a:ext cx="4754880" cy="5029200"/>
+          </a:xfrm>
+          <a:prstGeom prst="roundRect">
+            <a:avLst/>
+          </a:prstGeom>
+          <a:solidFill>
+            <a:srgbClr val="F8FAFC"/>
+          </a:solidFill>
+          <a:ln w="19050">
+            <a:solidFill>
+              <a:srgbClr val="E2E8F0"/>
+            </a:solidFill>
+          </a:ln>
+        </p:spPr>
+        <p:style>
+          <a:lnRef idx="1">
+            <a:schemeClr val="accent1"/>
+          </a:lnRef>
+          <a:fillRef idx="3">
+            <a:schemeClr val="accent1"/>
+          </a:fillRef>
+          <a:effectRef idx="2">
+            <a:schemeClr val="accent1"/>
+          </a:effectRef>
+          <a:fontRef idx="minor">
+            <a:schemeClr val="lt1"/>
+          </a:fontRef>
+        </p:style>
+        <p:txBody>
+          <a:bodyPr rtlCol="0" anchor="ctr" wrap="square"/>
+          <a:lstStyle/>
+          <a:p>
+            <a:pPr algn="ctr">
+              <a:defRPr sz="1050" b="1">
+                <a:solidFill>
+                  <a:srgbClr val="8B5CF6"/>
+                </a:solidFill>
+              </a:defRPr>
+            </a:pPr>
+            <a:r>
+              <a:t>🏛️ DERIVED WORLD INVARIANT (TIER 0)</a:t>
+            </a:r>
+          </a:p>
+          <a:p>
+            <a:pPr>
+              <a:defRPr sz="930">
+                <a:solidFill>
+                  <a:srgbClr val="0F172A"/>
+                </a:solidFill>
+              </a:defRPr>
+            </a:pPr>
+            <a:r>
+              <a:t>World Invariant: Fruitless Mountain is completely barren; nothing grows on it and birds/animals do not rest there. The mud village land is stubbornly poor. Minli has an impulsive, quick-acting nature.</a:t>
+            </a:r>
+          </a:p>
+          <a:p>
+            <a:br/>
+            <a:pPr>
+              <a:defRPr sz="1050" b="1">
+                <a:solidFill>
+                  <a:srgbClr val="0284C7"/>
+                </a:solidFill>
+              </a:defRPr>
+            </a:pPr>
+            <a:r>
+              <a:t>📏 GROUND TRUTH BOUNDS (EXACT LIMITS)</a:t>
+            </a:r>
+          </a:p>
+          <a:p>
+            <a:pPr>
+              <a:defRPr sz="930">
+                <a:solidFill>
+                  <a:srgbClr val="0F172A"/>
+                </a:solidFill>
+              </a:defRPr>
+            </a:pPr>
+            <a:r>
+              <a:t>Exact Family Bounds: only 3 people live in the house (Minli, Father, Mother).</a:t>
+            </a:r>
+            <a:br/>
+            <a:r>
+              <a:t>House Bound: tiny boards tied with twine.</a:t>
+            </a:r>
+            <a:br/>
+            <a:r>
+              <a:t>Geography: the corner where Fruitless Mountain and Jade River meet.</a:t>
+            </a:r>
+          </a:p>
+          <a:p>
+            <a:br/>
+            <a:pPr>
+              <a:defRPr sz="1050" b="1">
+                <a:solidFill>
+                  <a:srgbClr val="EF4444"/>
+                </a:solidFill>
+              </a:defRPr>
+            </a:pPr>
+            <a:r>
+              <a:t>⚡ EXECUTABLE DAG &amp; CIRCUIT BREAKER</a:t>
+            </a:r>
+          </a:p>
+          <a:p>
+            <a:pPr>
+              <a:defRPr sz="930">
+                <a:solidFill>
+                  <a:srgbClr val="0F172A"/>
+                </a:solidFill>
+              </a:defRPr>
+            </a:pPr>
+            <a:r>
+              <a:t>Instead of IT jargon, the DAG maps the real dramatic dilemma: Accept Poverty &amp; Stagnate vs. Follow Impulsive Spirit and embark on the quest to find the Old Man of the Moon to change her family's fortune.</a:t>
+            </a:r>
+          </a:p>
+        </p:txBody>
+      </p:sp>
+      <p:pic>
+        <p:nvPicPr>
+          <p:cNvPr id="5" name="Picture 4" descr="verified_flowchart_expanded_big.png"/>
+          <p:cNvPicPr>
+            <a:picLocks noChangeAspect="1"/>
+          </p:cNvPicPr>
+          <p:nvPr/>
+        </p:nvPicPr>
+        <p:blipFill>
+          <a:blip r:embed="rId2"/>
+          <a:stretch>
+            <a:fillRect/>
+          </a:stretch>
+        </p:blipFill>
+        <p:spPr>
+          <a:xfrm>
+            <a:off x="5669280" y="1371600"/>
+            <a:ext cx="5788152" cy="5029200"/>
+          </a:xfrm>
+          <a:prstGeom prst="rect">
+            <a:avLst/>
+          </a:prstGeom>
+        </p:spPr>
+      </p:pic>
+    </p:spTree>
+  </p:cSld>
+  <p:clrMapOvr>
+    <a:masterClrMapping/>
+  </p:clrMapOvr>
+</p:sld>
+</file>
+
+<file path=ppt/slides/slide12.xml><?xml version="1.0" encoding="utf-8"?>
+<p:sld xmlns:a="http://schemas.openxmlformats.org/drawingml/2006/main" xmlns:p="http://schemas.openxmlformats.org/presentationml/2006/main" xmlns:r="http://schemas.openxmlformats.org/officeDocument/2006/relationships">
+  <p:cSld>
+    <p:bg>
+      <p:bgPr>
+        <a:solidFill>
+          <a:srgbClr val="FFFFFF"/>
+        </a:solidFill>
+        <a:effectLst/>
+      </p:bgPr>
+    </p:bg>
+    <p:spTree>
+      <p:nvGrpSpPr>
+        <p:cNvPr id="1" name=""/>
+        <p:cNvGrpSpPr/>
+        <p:nvPr/>
+      </p:nvGrpSpPr>
+      <p:grpSpPr/>
+      <p:sp>
+        <p:nvSpPr>
+          <p:cNvPr id="2" name="TextBox 1"/>
+          <p:cNvSpPr txBox="1"/>
+          <p:nvPr/>
+        </p:nvSpPr>
+        <p:spPr>
+          <a:xfrm>
+            <a:off x="731520" y="320040"/>
+            <a:ext cx="7315200" cy="292608"/>
+          </a:xfrm>
+          <a:prstGeom prst="rect">
+            <a:avLst/>
+          </a:prstGeom>
+          <a:noFill/>
+        </p:spPr>
+        <p:txBody>
+          <a:bodyPr wrap="square">
+            <a:spAutoFit/>
+          </a:bodyPr>
+          <a:lstStyle/>
+          <a:p>
+            <a:pPr>
+              <a:defRPr sz="1000" b="1">
+                <a:solidFill>
+                  <a:srgbClr val="0284C7"/>
+                </a:solidFill>
+              </a:defRPr>
+            </a:pPr>
+            <a:r>
+              <a:t>📘 GROUNDTRUTH ARCHITECTURE PRINCIPLES</a:t>
+            </a:r>
+          </a:p>
+        </p:txBody>
+      </p:sp>
+      <p:sp>
+        <p:nvSpPr>
+          <p:cNvPr id="3" name="TextBox 2"/>
+          <p:cNvSpPr txBox="1"/>
+          <p:nvPr/>
+        </p:nvSpPr>
+        <p:spPr>
+          <a:xfrm>
+            <a:off x="731520" y="594360"/>
+            <a:ext cx="10515600" cy="502920"/>
+          </a:xfrm>
+          <a:prstGeom prst="rect">
+            <a:avLst/>
+          </a:prstGeom>
+          <a:noFill/>
+        </p:spPr>
+        <p:txBody>
+          <a:bodyPr wrap="square">
+            <a:spAutoFit/>
+          </a:bodyPr>
+          <a:lstStyle/>
+          <a:p>
+            <a:pPr>
+              <a:defRPr sz="2100" b="1">
+                <a:solidFill>
+                  <a:srgbClr val="0F172A"/>
+                </a:solidFill>
+              </a:defRPr>
+            </a:pPr>
+            <a:r>
+              <a:t>The GroundTruth Formula: From Raw Input to Reliable Agent</a:t>
+            </a:r>
+          </a:p>
+        </p:txBody>
+      </p:sp>
+      <p:sp>
+        <p:nvSpPr>
+          <p:cNvPr id="4" name="TextBox 3"/>
+          <p:cNvSpPr txBox="1"/>
+          <p:nvPr/>
+        </p:nvSpPr>
+        <p:spPr>
+          <a:xfrm>
+            <a:off x="731520" y="1078992"/>
+            <a:ext cx="10515600" cy="292608"/>
+          </a:xfrm>
+          <a:prstGeom prst="rect">
+            <a:avLst/>
+          </a:prstGeom>
+          <a:noFill/>
+        </p:spPr>
+        <p:txBody>
+          <a:bodyPr wrap="square">
+            <a:spAutoFit/>
+          </a:bodyPr>
+          <a:lstStyle/>
+          <a:p>
+            <a:pPr>
+              <a:defRPr sz="1100">
+                <a:solidFill>
+                  <a:srgbClr val="64748B"/>
+                </a:solidFill>
+              </a:defRPr>
+            </a:pPr>
+            <a:r>
+              <a:t>How the 5-Tier Policy Tree and DAG Circuit Breakers eliminate hallucination across any domain.</a:t>
+            </a:r>
+          </a:p>
+        </p:txBody>
+      </p:sp>
+      <p:sp>
+        <p:nvSpPr>
+          <p:cNvPr id="5" name="Rounded Rectangle 4"/>
+          <p:cNvSpPr/>
+          <p:nvPr/>
+        </p:nvSpPr>
+        <p:spPr>
+          <a:xfrm>
+            <a:off x="731520" y="1463040"/>
+            <a:ext cx="10728655" cy="4754880"/>
+          </a:xfrm>
+          <a:prstGeom prst="roundRect">
+            <a:avLst/>
+          </a:prstGeom>
+          <a:solidFill>
+            <a:srgbClr val="F8FAFC"/>
+          </a:solidFill>
+          <a:ln w="19050">
+            <a:solidFill>
+              <a:srgbClr val="CBD5E1"/>
+            </a:solidFill>
+          </a:ln>
+        </p:spPr>
+        <p:style>
+          <a:lnRef idx="1">
+            <a:schemeClr val="accent1"/>
+          </a:lnRef>
+          <a:fillRef idx="3">
+            <a:schemeClr val="accent1"/>
+          </a:fillRef>
+          <a:effectRef idx="2">
+            <a:schemeClr val="accent1"/>
+          </a:effectRef>
+          <a:fontRef idx="minor">
+            <a:schemeClr val="lt1"/>
+          </a:fontRef>
+        </p:style>
+        <p:txBody>
+          <a:bodyPr rtlCol="0" anchor="ctr" wrap="square"/>
+          <a:lstStyle/>
+          <a:p>
+            <a:pPr algn="ctr">
+              <a:defRPr sz="1300" b="1">
+                <a:solidFill>
+                  <a:srgbClr val="0284C7"/>
+                </a:solidFill>
+              </a:defRPr>
+            </a:pPr>
+            <a:r>
+              <a:t>🎯 4 KEY TAKEAWAYS FOR ENTERPRISE AI ARCHITECTS</a:t>
+            </a:r>
+          </a:p>
+          <a:p>
+            <a:br/>
+            <a:pPr>
+              <a:defRPr sz="1100" b="1">
+                <a:solidFill>
+                  <a:srgbClr val="0F172A"/>
+                </a:solidFill>
+              </a:defRPr>
+            </a:pPr>
+            <a:r>
+              <a:t>• 1. Always Pair Raw Input with Compiled Ground Truth</a:t>
+            </a:r>
+          </a:p>
+          <a:p>
+            <a:pPr>
+              <a:defRPr sz="1000">
+                <a:solidFill>
+                  <a:srgbClr val="475569"/>
+                </a:solidFill>
+              </a:defRPr>
+            </a:pPr>
+            <a:r>
+              <a:t>   Showing only the output hides how the agent achieved fidelity. True accountability requires capturing the raw source document and web interface side-by-side with the synthesized DAG.</a:t>
+            </a:r>
+          </a:p>
+          <a:p>
+            <a:br/>
+            <a:pPr>
+              <a:defRPr sz="1100" b="1">
+                <a:solidFill>
+                  <a:srgbClr val="0F172A"/>
+                </a:solidFill>
+              </a:defRPr>
+            </a:pPr>
+            <a:r>
+              <a:t>• 2. Zero Hallucinated Numbers — Respect Algebraic Bounds</a:t>
+            </a:r>
+          </a:p>
+          <a:p>
+            <a:pPr>
+              <a:defRPr sz="1000">
+                <a:solidFill>
+                  <a:srgbClr val="475569"/>
+                </a:solidFill>
+              </a:defRPr>
+            </a:pPr>
+            <a:r>
+              <a:t>   If a source doesn't specify physical constants, keep them algebraic. Inventing 42 kPa or $1.5% from thin air is a catastrophic failure of ground truth.</a:t>
+            </a:r>
+          </a:p>
+          <a:p>
+            <a:br/>
+            <a:pPr>
+              <a:defRPr sz="1100" b="1">
+                <a:solidFill>
+                  <a:srgbClr val="0F172A"/>
+                </a:solidFill>
+              </a:defRPr>
+            </a:pPr>
+            <a:r>
+              <a:t>• 3. The 5-Tier Policy Hierarchy Bridges Any Domain</a:t>
+            </a:r>
+          </a:p>
+          <a:p>
+            <a:pPr>
+              <a:defRPr sz="1000">
+                <a:solidFill>
+                  <a:srgbClr val="475569"/>
+                </a:solidFill>
+              </a:defRPr>
+            </a:pPr>
+            <a:r>
+              <a:t>   Root Invariants ➔ Scoped Directives ➔ Execution Rules ➔ Parameter Bounds ➔ Dead Ends provides an immutable contract layer for both engineering runbooks and story plots.</a:t>
+            </a:r>
+          </a:p>
+          <a:p>
+            <a:br/>
+            <a:pPr>
+              <a:defRPr sz="1100" b="1">
+                <a:solidFill>
+                  <a:srgbClr val="0F172A"/>
+                </a:solidFill>
+              </a:defRPr>
+            </a:pPr>
+            <a:r>
+              <a:t>• 4. Circuit-Breaker DAGs Enforce Deterministic Safety</a:t>
+            </a:r>
+          </a:p>
+          <a:p>
+            <a:pPr>
+              <a:defRPr sz="1000">
+                <a:solidFill>
+                  <a:srgbClr val="475569"/>
+                </a:solidFill>
+              </a:defRPr>
+            </a:pPr>
+            <a:r>
+              <a:t>   By compiling invariants directly into LangGraph decision nodes and tripwire terminals, agents are evaluated and constrained by a deterministic hidden answer key.</a:t>
             </a:r>
           </a:p>
         </p:txBody>
@@ -3240,8 +4034,8 @@
         </p:nvSpPr>
         <p:spPr>
           <a:xfrm>
-            <a:off x="731520" y="365760"/>
-            <a:ext cx="7315200" cy="320040"/>
+            <a:off x="731520" y="320040"/>
+            <a:ext cx="7315200" cy="292608"/>
           </a:xfrm>
           <a:prstGeom prst="rect">
             <a:avLst/>
@@ -3275,8 +4069,8 @@
         </p:nvSpPr>
         <p:spPr>
           <a:xfrm>
-            <a:off x="731520" y="640080"/>
-            <a:ext cx="10058400" cy="594360"/>
+            <a:off x="731520" y="594360"/>
+            <a:ext cx="10515600" cy="502920"/>
           </a:xfrm>
           <a:prstGeom prst="rect">
             <a:avLst/>
@@ -3290,7 +4084,7 @@
           <a:lstStyle/>
           <a:p>
             <a:pPr>
-              <a:defRPr sz="2200" b="1">
+              <a:defRPr sz="2100" b="1">
                 <a:solidFill>
                   <a:srgbClr val="0F172A"/>
                 </a:solidFill>
@@ -3310,8 +4104,8 @@
         </p:nvSpPr>
         <p:spPr>
           <a:xfrm>
-            <a:off x="731520" y="1188720"/>
-            <a:ext cx="10515600" cy="320040"/>
+            <a:off x="731520" y="1078992"/>
+            <a:ext cx="10515600" cy="292608"/>
           </a:xfrm>
           <a:prstGeom prst="rect">
             <a:avLst/>
@@ -3345,8 +4139,8 @@
         </p:nvSpPr>
         <p:spPr>
           <a:xfrm>
-            <a:off x="731520" y="1645920"/>
-            <a:ext cx="3429000" cy="4389120"/>
+            <a:off x="731520" y="1463040"/>
+            <a:ext cx="3429000" cy="4754880"/>
           </a:xfrm>
           <a:prstGeom prst="roundRect">
             <a:avLst/>
@@ -3399,12 +4193,12 @@
               </a:defRPr>
             </a:pPr>
             <a:r>
-              <a:t>If a source (like Wikipedia) defines an optimization formula algebraically as J = sum(w*(r-x)^2), DO NOT invent a fake 42.0 kPa ceiling.</a:t>
+              <a:t>If a source defines an optimization formula algebraically as J = sum(w*(r-x)^2), DO NOT invent a fake 42.0 kPa ceiling.</a:t>
             </a:r>
             <a:br/>
             <a:br/>
             <a:r>
-              <a:t>Ground truth means exact fidelity: keep unspecified bounds algebraic and extract ONLY what exists.</a:t>
+              <a:t>Ground truth means exact fidelity: keep unspecified bounds algebraic and extract ONLY what exists in the input.</a:t>
             </a:r>
           </a:p>
         </p:txBody>
@@ -3417,8 +4211,8 @@
         </p:nvSpPr>
         <p:spPr>
           <a:xfrm>
-            <a:off x="4389120" y="1645920"/>
-            <a:ext cx="3429000" cy="4389120"/>
+            <a:off x="4389120" y="1463040"/>
+            <a:ext cx="3429000" cy="4754880"/>
           </a:xfrm>
           <a:prstGeom prst="roundRect">
             <a:avLst/>
@@ -3471,12 +4265,12 @@
               </a:defRPr>
             </a:pPr>
             <a:r>
-              <a:t>World Invariants are what the ENVIRONMENT enforces (gravity, token expiration, barren soil).</a:t>
+              <a:t>World Invariants are what the ENVIRONMENT enforces (gravity, token expiration, barren soil, federal laws).</a:t>
             </a:r>
             <a:br/>
             <a:br/>
             <a:r>
-              <a:t>Agent Policies are choices the actor makes. Policies can bend; world physics never bend for any prompt.</a:t>
+              <a:t>Agent Policies are choices the actor makes. Strategy can bend; world invariants never bend for any prompt.</a:t>
             </a:r>
           </a:p>
         </p:txBody>
@@ -3489,8 +4283,8 @@
         </p:nvSpPr>
         <p:spPr>
           <a:xfrm>
-            <a:off x="8046720" y="1645920"/>
-            <a:ext cx="3429000" cy="4389120"/>
+            <a:off x="8046720" y="1463040"/>
+            <a:ext cx="3429000" cy="4754880"/>
           </a:xfrm>
           <a:prstGeom prst="roundRect">
             <a:avLst/>
@@ -3548,7 +4342,7 @@
             <a:br/>
             <a:br/>
             <a:r>
-              <a:t>If state telemetry crosses the boundary, execution freezes instantly into safe fallback.</a:t>
+              <a:t>If telemetry crosses the boundary, execution freezes instantly into a deterministic safe fallback.</a:t>
             </a:r>
           </a:p>
         </p:txBody>
@@ -3587,8 +4381,8 @@
         </p:nvSpPr>
         <p:spPr>
           <a:xfrm>
-            <a:off x="731520" y="365760"/>
-            <a:ext cx="7315200" cy="320040"/>
+            <a:off x="731520" y="320040"/>
+            <a:ext cx="7315200" cy="292608"/>
           </a:xfrm>
           <a:prstGeom prst="rect">
             <a:avLst/>
@@ -3609,7 +4403,7 @@
               </a:defRPr>
             </a:pPr>
             <a:r>
-              <a:t>📘 EXAMPLE 01: ENTERPRISE IDENTITY &amp; SOC2 COMPLIANCE</a:t>
+              <a:t>📘 GROUNDTRUTH ARCHITECTURE PRINCIPLES</a:t>
             </a:r>
           </a:p>
         </p:txBody>
@@ -3622,8 +4416,8 @@
         </p:nvSpPr>
         <p:spPr>
           <a:xfrm>
-            <a:off x="731520" y="640080"/>
-            <a:ext cx="10058400" cy="594360"/>
+            <a:off x="731520" y="594360"/>
+            <a:ext cx="10515600" cy="502920"/>
           </a:xfrm>
           <a:prstGeom prst="rect">
             <a:avLst/>
@@ -3637,38 +4431,73 @@
           <a:lstStyle/>
           <a:p>
             <a:pPr>
-              <a:defRPr sz="2200" b="1">
+              <a:defRPr sz="2100" b="1">
                 <a:solidFill>
                   <a:srgbClr val="0F172A"/>
                 </a:solidFill>
               </a:defRPr>
             </a:pPr>
             <a:r>
-              <a:t>Enterprise IT Security: FIDO2 &amp; Break-Glass Governance</a:t>
-            </a:r>
-          </a:p>
-        </p:txBody>
-      </p:sp>
-      <p:sp>
-        <p:nvSpPr>
-          <p:cNvPr id="4" name="Rounded Rectangle 3"/>
+              <a:t>The Dual-Input Architecture: Two Sources of Truth</a:t>
+            </a:r>
+          </a:p>
+        </p:txBody>
+      </p:sp>
+      <p:sp>
+        <p:nvSpPr>
+          <p:cNvPr id="4" name="TextBox 3"/>
+          <p:cNvSpPr txBox="1"/>
+          <p:nvPr/>
+        </p:nvSpPr>
+        <p:spPr>
+          <a:xfrm>
+            <a:off x="731520" y="1078992"/>
+            <a:ext cx="10515600" cy="292608"/>
+          </a:xfrm>
+          <a:prstGeom prst="rect">
+            <a:avLst/>
+          </a:prstGeom>
+          <a:noFill/>
+        </p:spPr>
+        <p:txBody>
+          <a:bodyPr wrap="square">
+            <a:spAutoFit/>
+          </a:bodyPr>
+          <a:lstStyle/>
+          <a:p>
+            <a:pPr>
+              <a:defRPr sz="1100">
+                <a:solidFill>
+                  <a:srgbClr val="64748B"/>
+                </a:solidFill>
+              </a:defRPr>
+            </a:pPr>
+            <a:r>
+              <a:t>How the GroundTruth engine combines static policy contracts with dynamic live web interfaces.</a:t>
+            </a:r>
+          </a:p>
+        </p:txBody>
+      </p:sp>
+      <p:sp>
+        <p:nvSpPr>
+          <p:cNvPr id="5" name="Rounded Rectangle 4"/>
           <p:cNvSpPr/>
           <p:nvPr/>
         </p:nvSpPr>
         <p:spPr>
           <a:xfrm>
             <a:off x="731520" y="1463040"/>
-            <a:ext cx="4389120" cy="4846320"/>
+            <a:ext cx="5257800" cy="3108960"/>
           </a:xfrm>
           <a:prstGeom prst="roundRect">
             <a:avLst/>
           </a:prstGeom>
           <a:solidFill>
-            <a:srgbClr val="F8FAFC"/>
+            <a:srgbClr val="F0F9FF"/>
           </a:solidFill>
           <a:ln w="19050">
             <a:solidFill>
-              <a:srgbClr val="E2E8F0"/>
+              <a:srgbClr val="0284C7"/>
             </a:solidFill>
           </a:ln>
         </p:spPr>
@@ -3691,108 +4520,222 @@
           <a:lstStyle/>
           <a:p>
             <a:pPr algn="ctr">
-              <a:defRPr sz="1100" b="1">
+              <a:defRPr sz="1300" b="1">
                 <a:solidFill>
                   <a:srgbClr val="0284C7"/>
                 </a:solidFill>
               </a:defRPr>
             </a:pPr>
             <a:r>
-              <a:t>🏛️ THE WORLD INVARIANT</a:t>
-            </a:r>
-          </a:p>
-          <a:p>
-            <a:pPr>
-              <a:defRPr sz="1000">
+              <a:t>📄 Input 1: Custom Document / Policy / SOP / Excerpt</a:t>
+            </a:r>
+          </a:p>
+          <a:p>
+            <a:pPr>
+              <a:defRPr sz="1000" b="1">
+                <a:solidFill>
+                  <a:srgbClr val="64748B"/>
+                </a:solidFill>
+              </a:defRPr>
+            </a:pPr>
+            <a:r>
+              <a:t>The Normative &amp; Contractual Reality</a:t>
+            </a:r>
+          </a:p>
+          <a:p>
+            <a:br/>
+            <a:pPr>
+              <a:defRPr sz="1050">
                 <a:solidFill>
                   <a:srgbClr val="0F172A"/>
                 </a:solidFill>
               </a:defRPr>
             </a:pPr>
             <a:r>
-              <a:t>Hardware FIDO2 WebAuthn cryptographic keys are strictly mandatory across production VPCs. Legacy SMS OTP and voice telephone MFA are STRICTLY PROHIBITED due to SIM-swapping vulnerabilities.</a:t>
-            </a:r>
-          </a:p>
-          <a:p>
+              <a:t>The user provides raw human prose: corporate SOPs, regulatory statutes, runbooks, or literary narratives.</a:t>
+            </a:r>
             <a:br/>
-            <a:pPr>
-              <a:defRPr sz="1100" b="1">
-                <a:solidFill>
-                  <a:srgbClr val="0284C7"/>
-                </a:solidFill>
-              </a:defRPr>
-            </a:pPr>
-            <a:r>
-              <a:t>📏 GROUND TRUTH BOUNDS</a:t>
-            </a:r>
-          </a:p>
-          <a:p>
-            <a:pPr>
-              <a:defRPr sz="1000">
-                <a:solidFill>
-                  <a:srgbClr val="0F172A"/>
-                </a:solidFill>
-              </a:defRPr>
-            </a:pPr>
-            <a:r>
-              <a:t>Direct database write lease TTL: capped at exactly 4 HOURS (240 minutes).</a:t>
-            </a:r>
             <a:br/>
             <a:r>
-              <a:t>Emergency Break-Glass tokens: hard-capped at exactly 2 HOURS (7,200 seconds).</a:t>
-            </a:r>
-          </a:p>
-          <a:p>
+              <a:t>• Defines root axioms, permission bounds, and hard prohibitions.</a:t>
+            </a:r>
             <a:br/>
-            <a:pPr>
-              <a:defRPr sz="1100" b="1">
-                <a:solidFill>
-                  <a:srgbClr val="EF4444"/>
-                </a:solidFill>
-              </a:defRPr>
-            </a:pPr>
-            <a:r>
-              <a:t>⚡ DAG CIRCUIT BREAKER</a:t>
-            </a:r>
-          </a:p>
-          <a:p>
-            <a:pPr>
-              <a:defRPr sz="1000">
-                <a:solidFill>
-                  <a:srgbClr val="0F172A"/>
-                </a:solidFill>
-              </a:defRPr>
-            </a:pPr>
-            <a:r>
-              <a:t>The DAG intercepts unauthorized escalations: if Break-Glass token expires at 2 hours, it instantly terminates DB leases, reverts credentials, and dispatches an immutable SOC2 audit incident to SIRT.</a:t>
-            </a:r>
-          </a:p>
-        </p:txBody>
-      </p:sp>
-      <p:pic>
-        <p:nvPicPr>
-          <p:cNvPr id="5" name="Picture 4" descr="app8_it_security_flowchart.png"/>
-          <p:cNvPicPr>
-            <a:picLocks noChangeAspect="1"/>
-          </p:cNvPicPr>
+            <a:r>
+              <a:t>• Contains the world invariants that must NEVER be violated.</a:t>
+            </a:r>
+            <a:br/>
+            <a:r>
+              <a:t>• Unstructured and messy in raw form — requires structured parsing.</a:t>
+            </a:r>
+          </a:p>
+        </p:txBody>
+      </p:sp>
+      <p:sp>
+        <p:nvSpPr>
+          <p:cNvPr id="6" name="Rounded Rectangle 5"/>
+          <p:cNvSpPr/>
           <p:nvPr/>
-        </p:nvPicPr>
-        <p:blipFill>
-          <a:blip r:embed="rId2"/>
-          <a:stretch>
-            <a:fillRect/>
-          </a:stretch>
-        </p:blipFill>
-        <p:spPr>
-          <a:xfrm>
-            <a:off x="5303520" y="1463040"/>
-            <a:ext cx="6126480" cy="4846320"/>
-          </a:xfrm>
-          <a:prstGeom prst="rect">
+        </p:nvSpPr>
+        <p:spPr>
+          <a:xfrm>
+            <a:off x="6172200" y="1463040"/>
+            <a:ext cx="5257800" cy="3108960"/>
+          </a:xfrm>
+          <a:prstGeom prst="roundRect">
             <a:avLst/>
           </a:prstGeom>
-        </p:spPr>
-      </p:pic>
+          <a:solidFill>
+            <a:srgbClr val="F5F3FF"/>
+          </a:solidFill>
+          <a:ln w="19050">
+            <a:solidFill>
+              <a:srgbClr val="8B5CF6"/>
+            </a:solidFill>
+          </a:ln>
+        </p:spPr>
+        <p:style>
+          <a:lnRef idx="1">
+            <a:schemeClr val="accent1"/>
+          </a:lnRef>
+          <a:fillRef idx="3">
+            <a:schemeClr val="accent1"/>
+          </a:fillRef>
+          <a:effectRef idx="2">
+            <a:schemeClr val="accent1"/>
+          </a:effectRef>
+          <a:fontRef idx="minor">
+            <a:schemeClr val="lt1"/>
+          </a:fontRef>
+        </p:style>
+        <p:txBody>
+          <a:bodyPr rtlCol="0" anchor="ctr" wrap="square"/>
+          <a:lstStyle/>
+          <a:p>
+            <a:pPr algn="ctr">
+              <a:defRPr sz="1300" b="1">
+                <a:solidFill>
+                  <a:srgbClr val="8B5CF6"/>
+                </a:solidFill>
+              </a:defRPr>
+            </a:pPr>
+            <a:r>
+              <a:t>🌐 Input 2: Web Address / Internal Portal URL</a:t>
+            </a:r>
+          </a:p>
+          <a:p>
+            <a:pPr>
+              <a:defRPr sz="1000" b="1">
+                <a:solidFill>
+                  <a:srgbClr val="64748B"/>
+                </a:solidFill>
+              </a:defRPr>
+            </a:pPr>
+            <a:r>
+              <a:t>The Empirical &amp; Operational Environment</a:t>
+            </a:r>
+          </a:p>
+          <a:p>
+            <a:br/>
+            <a:pPr>
+              <a:defRPr sz="1050">
+                <a:solidFill>
+                  <a:srgbClr val="0F172A"/>
+                </a:solidFill>
+              </a:defRPr>
+            </a:pPr>
+            <a:r>
+              <a:t>The live target interface where actions execute: an internal SSO portal, dispute microservice, canary router, or external URL.</a:t>
+            </a:r>
+            <a:br/>
+            <a:br/>
+            <a:r>
+              <a:t>• Supplies real-time observation telemetry.</a:t>
+            </a:r>
+            <a:br/>
+            <a:r>
+              <a:t>• Validates preconditions before dispatching mutations.</a:t>
+            </a:r>
+            <a:br/>
+            <a:r>
+              <a:t>• Exposes operational gates (APIs, routes, telemetry feeds).</a:t>
+            </a:r>
+          </a:p>
+        </p:txBody>
+      </p:sp>
+      <p:sp>
+        <p:nvSpPr>
+          <p:cNvPr id="7" name="Rounded Rectangle 6"/>
+          <p:cNvSpPr/>
+          <p:nvPr/>
+        </p:nvSpPr>
+        <p:spPr>
+          <a:xfrm>
+            <a:off x="731520" y="4754880"/>
+            <a:ext cx="10728655" cy="1463040"/>
+          </a:xfrm>
+          <a:prstGeom prst="roundRect">
+            <a:avLst/>
+          </a:prstGeom>
+          <a:solidFill>
+            <a:srgbClr val="F8FAFC"/>
+          </a:solidFill>
+          <a:ln w="19050">
+            <a:solidFill>
+              <a:srgbClr val="10B981"/>
+            </a:solidFill>
+          </a:ln>
+        </p:spPr>
+        <p:style>
+          <a:lnRef idx="1">
+            <a:schemeClr val="accent1"/>
+          </a:lnRef>
+          <a:fillRef idx="3">
+            <a:schemeClr val="accent1"/>
+          </a:fillRef>
+          <a:effectRef idx="2">
+            <a:schemeClr val="accent1"/>
+          </a:effectRef>
+          <a:fontRef idx="minor">
+            <a:schemeClr val="lt1"/>
+          </a:fontRef>
+        </p:style>
+        <p:txBody>
+          <a:bodyPr rtlCol="0" anchor="ctr" wrap="square"/>
+          <a:lstStyle/>
+          <a:p>
+            <a:pPr algn="ctr">
+              <a:defRPr sz="1150" b="1">
+                <a:solidFill>
+                  <a:srgbClr val="10B981"/>
+                </a:solidFill>
+              </a:defRPr>
+            </a:pPr>
+            <a:r>
+              <a:t>⚡ DUAL GOVERNANCE COMPILATION: FROM INTAKE TO EXECUTABLE DAG</a:t>
+            </a:r>
+          </a:p>
+          <a:p>
+            <a:pPr>
+              <a:defRPr sz="1050">
+                <a:solidFill>
+                  <a:srgbClr val="0F172A"/>
+                </a:solidFill>
+              </a:defRPr>
+            </a:pPr>
+            <a:r>
+              <a:t>When both inputs are ingested, the GroundTruth compiler synthesizes:</a:t>
+            </a:r>
+            <a:br/>
+            <a:r>
+              <a:t>1. Cascading Policy Tree (Text Contract): 5 Tiers of verified invariants, directives, and dead ends.</a:t>
+            </a:r>
+            <a:br/>
+            <a:r>
+              <a:t>2. Interactive Flowchart DAG (Executable Topology): Branching decision diamonds with automated circuit-breaker tripwires.</a:t>
+            </a:r>
+          </a:p>
+        </p:txBody>
+      </p:sp>
     </p:spTree>
   </p:cSld>
   <p:clrMapOvr>
@@ -3827,8 +4770,8 @@
         </p:nvSpPr>
         <p:spPr>
           <a:xfrm>
-            <a:off x="731520" y="365760"/>
-            <a:ext cx="7315200" cy="320040"/>
+            <a:off x="731520" y="320040"/>
+            <a:ext cx="7315200" cy="292608"/>
           </a:xfrm>
           <a:prstGeom prst="rect">
             <a:avLst/>
@@ -3849,7 +4792,7 @@
               </a:defRPr>
             </a:pPr>
             <a:r>
-              <a:t>📘 EXAMPLE 02: FINANCIAL CRIME &amp; REGULATORY COMPLIANCE</a:t>
+              <a:t>📘 EXAMPLE 01 (PART 1): ENTERPRISE IDENTITY &amp; SOC2 — ORIGINAL INPUT INTAKE</a:t>
             </a:r>
           </a:p>
         </p:txBody>
@@ -3862,8 +4805,8 @@
         </p:nvSpPr>
         <p:spPr>
           <a:xfrm>
-            <a:off x="731520" y="640080"/>
-            <a:ext cx="10058400" cy="594360"/>
+            <a:off x="731520" y="594360"/>
+            <a:ext cx="10515600" cy="502920"/>
           </a:xfrm>
           <a:prstGeom prst="rect">
             <a:avLst/>
@@ -3877,14 +4820,14 @@
           <a:lstStyle/>
           <a:p>
             <a:pPr>
-              <a:defRPr sz="2200" b="1">
+              <a:defRPr sz="2100" b="1">
                 <a:solidFill>
                   <a:srgbClr val="0F172A"/>
                 </a:solidFill>
               </a:defRPr>
             </a:pPr>
             <a:r>
-              <a:t>FinTech Dispute Intake: AML Velocity &amp; Federal Non-Tipping</a:t>
+              <a:t>IT Security: Original Ingestion &amp; Policy Document</a:t>
             </a:r>
           </a:p>
         </p:txBody>
@@ -3897,8 +4840,8 @@
         </p:nvSpPr>
         <p:spPr>
           <a:xfrm>
-            <a:off x="731520" y="1463040"/>
-            <a:ext cx="4389120" cy="4846320"/>
+            <a:off x="731520" y="1371600"/>
+            <a:ext cx="4754880" cy="5029200"/>
           </a:xfrm>
           <a:prstGeom prst="roundRect">
             <a:avLst/>
@@ -3931,91 +4874,103 @@
           <a:lstStyle/>
           <a:p>
             <a:pPr algn="ctr">
-              <a:defRPr sz="1100" b="1">
-                <a:solidFill>
-                  <a:srgbClr val="10B981"/>
-                </a:solidFill>
-              </a:defRPr>
-            </a:pPr>
-            <a:r>
-              <a:t>🏛️ THE WORLD INVARIANT</a:t>
-            </a:r>
-          </a:p>
-          <a:p>
-            <a:pPr>
-              <a:defRPr sz="1000">
+              <a:defRPr sz="1050" b="1">
+                <a:solidFill>
+                  <a:srgbClr val="0284C7"/>
+                </a:solidFill>
+              </a:defRPr>
+            </a:pPr>
+            <a:r>
+              <a:t>📥 INPUT 1: RAW SOURCE DOCUMENT / SOP</a:t>
+            </a:r>
+          </a:p>
+          <a:p>
+            <a:pPr>
+              <a:defRPr sz="950" b="1">
                 <a:solidFill>
                   <a:srgbClr val="0F172A"/>
                 </a:solidFill>
               </a:defRPr>
             </a:pPr>
             <a:r>
-              <a:t>Federal Non-Tipping Invariant (31 U.S.C. 5318(g)): Agents and customer support are STRICTLY PROHIBITED from tipping off customers about Suspicious Activity Report (SAR) filings or AML freezes.</a:t>
-            </a:r>
-          </a:p>
-          <a:p>
+              <a:t>Title: SEC-POL-402_Rev4: Enterprise IT SSO &amp; Privilege Escalation Policy</a:t>
+            </a:r>
+          </a:p>
+          <a:p>
+            <a:pPr>
+              <a:defRPr sz="900" i="1">
+                <a:solidFill>
+                  <a:srgbClr val="334155"/>
+                </a:solidFill>
+              </a:defRPr>
+            </a:pPr>
+            <a:r>
+              <a:t>"§ 1.0 Multi-Factor Authentication (MFA) Mandate: All engineers, contractor personnel, and automated system accounts accessing production VPCs... must authenticate using physical, hardware-backed FIDO2 WebAuthn cryptographic keys (e.g. YubiKey 5 Series). Legacy SMS OTP and voice-call telephone verifications are STRICTLY PROHIBITED.</a:t>
+            </a:r>
             <a:br/>
-            <a:pPr>
-              <a:defRPr sz="1100" b="1">
+            <a:r>
+              <a:t>§ 2.0 Elevated Database Write Leases: Elevated access leases are strictly ephemeral: TTL SHALL NOT EXCEED 4 HOURS (240 minutes).</a:t>
+            </a:r>
+            <a:br/>
+            <a:r>
+              <a:t>§ 3.0 Emergency Break-Glass: Break-Glass tokens are hard-capped at 2 HOURS (7,200 SECONDS). A non-dismissible audit event is dispatched instantly to SIRT."</a:t>
+            </a:r>
+          </a:p>
+          <a:p>
+            <a:br/>
+            <a:pPr>
+              <a:defRPr sz="1050" b="1">
                 <a:solidFill>
                   <a:srgbClr val="0284C7"/>
                 </a:solidFill>
               </a:defRPr>
             </a:pPr>
             <a:r>
-              <a:t>📏 GROUND TRUTH BOUNDS</a:t>
-            </a:r>
-          </a:p>
-          <a:p>
-            <a:pPr>
-              <a:defRPr sz="1000">
+              <a:t>🌐 INPUT 2: WEB ADDRESS / TARGET ENDPOINT</a:t>
+            </a:r>
+          </a:p>
+          <a:p>
+            <a:pPr>
+              <a:defRPr sz="950" b="1">
                 <a:solidFill>
                   <a:srgbClr val="0F172A"/>
                 </a:solidFill>
               </a:defRPr>
             </a:pPr>
             <a:r>
-              <a:t>Instant Tier-1 Provisional Credit: EQUAL TO OR LESS THAN $150.00.</a:t>
-            </a:r>
+              <a:t>URL: https://internal.corp.local/overview</a:t>
+            </a:r>
+          </a:p>
+          <a:p>
             <a:br/>
-            <a:r>
-              <a:t>High-Velocity AML Hold Window: exactly 72 HOURS.</a:t>
-            </a:r>
-            <a:br/>
-            <a:r>
-              <a:t>Merchant Delivery Proof Rebuttal: strictly 5 business days.</a:t>
-            </a:r>
-          </a:p>
-          <a:p>
-            <a:br/>
-            <a:pPr>
-              <a:defRPr sz="1100" b="1">
+            <a:pPr>
+              <a:defRPr sz="1050" b="1">
                 <a:solidFill>
                   <a:srgbClr val="EF4444"/>
                 </a:solidFill>
               </a:defRPr>
             </a:pPr>
             <a:r>
-              <a:t>⚡ DAG CIRCUIT BREAKER</a:t>
-            </a:r>
-          </a:p>
-          <a:p>
-            <a:pPr>
-              <a:defRPr sz="1000">
+              <a:t>⚠️ WHY NAIVE LLMS FAIL ON THIS INPUT</a:t>
+            </a:r>
+          </a:p>
+          <a:p>
+            <a:pPr>
+              <a:defRPr sz="919">
                 <a:solidFill>
                   <a:srgbClr val="0F172A"/>
                 </a:solidFill>
               </a:defRPr>
             </a:pPr>
             <a:r>
-              <a:t>The DAG routes claims &lt; $150 to automated reversal. If 24h card velocity exceeds $5,000, it instantly routes into a 72-hour frozen gate. Missing tracking proof triggers automatic merchant forfeiture.</a:t>
+              <a:t>Without strict invariant extraction, an LLM easily falls back to 'helpful' user options like sending an SMS code during login friction, directly violating SOC2 hardware token requirements. It also tends to round lease timers or fail to trigger immediate SIRT alerts.</a:t>
             </a:r>
           </a:p>
         </p:txBody>
       </p:sp>
       <p:pic>
         <p:nvPicPr>
-          <p:cNvPr id="5" name="Picture 4" descr="app8_fintech_dispute_flowchart.png"/>
+          <p:cNvPr id="5" name="Picture 4" descr="app8_it_security_step1.png"/>
           <p:cNvPicPr>
             <a:picLocks noChangeAspect="1"/>
           </p:cNvPicPr>
@@ -4029,8 +4984,8 @@
         </p:blipFill>
         <p:spPr>
           <a:xfrm>
-            <a:off x="5303520" y="1463040"/>
-            <a:ext cx="6126480" cy="4846320"/>
+            <a:off x="5669280" y="1371600"/>
+            <a:ext cx="5788152" cy="5029200"/>
           </a:xfrm>
           <a:prstGeom prst="rect">
             <a:avLst/>
@@ -4071,8 +5026,8 @@
         </p:nvSpPr>
         <p:spPr>
           <a:xfrm>
-            <a:off x="731520" y="365760"/>
-            <a:ext cx="7315200" cy="320040"/>
+            <a:off x="731520" y="320040"/>
+            <a:ext cx="7315200" cy="292608"/>
           </a:xfrm>
           <a:prstGeom prst="rect">
             <a:avLst/>
@@ -4093,7 +5048,7 @@
               </a:defRPr>
             </a:pPr>
             <a:r>
-              <a:t>📘 EXAMPLE 03: SITE RELIABILITY ENGINEERING (SRE)</a:t>
+              <a:t>📘 EXAMPLE 01 (PART 2): ENTERPRISE IDENTITY &amp; SOC2 — GROUND TRUTH OUTPUT &amp; DAG</a:t>
             </a:r>
           </a:p>
         </p:txBody>
@@ -4106,8 +5061,8 @@
         </p:nvSpPr>
         <p:spPr>
           <a:xfrm>
-            <a:off x="731520" y="640080"/>
-            <a:ext cx="10058400" cy="594360"/>
+            <a:off x="731520" y="594360"/>
+            <a:ext cx="10515600" cy="502920"/>
           </a:xfrm>
           <a:prstGeom prst="rect">
             <a:avLst/>
@@ -4121,14 +5076,14 @@
           <a:lstStyle/>
           <a:p>
             <a:pPr>
-              <a:defRPr sz="2200" b="1">
+              <a:defRPr sz="2100" b="1">
                 <a:solidFill>
                   <a:srgbClr val="0F172A"/>
                 </a:solidFill>
               </a:defRPr>
             </a:pPr>
             <a:r>
-              <a:t>Cloud DevOps: Canary Rollouts &amp; Zero-Downtime DDL Locks</a:t>
+              <a:t>IT Security: Compiled Ground Truth &amp; Flowchart DAG</a:t>
             </a:r>
           </a:p>
         </p:txBody>
@@ -4141,8 +5096,8 @@
         </p:nvSpPr>
         <p:spPr>
           <a:xfrm>
-            <a:off x="731520" y="1463040"/>
-            <a:ext cx="4389120" cy="4846320"/>
+            <a:off x="731520" y="1371600"/>
+            <a:ext cx="4754880" cy="5029200"/>
           </a:xfrm>
           <a:prstGeom prst="roundRect">
             <a:avLst/>
@@ -4175,87 +5130,87 @@
           <a:lstStyle/>
           <a:p>
             <a:pPr algn="ctr">
-              <a:defRPr sz="1100" b="1">
-                <a:solidFill>
-                  <a:srgbClr val="F59E0B"/>
-                </a:solidFill>
-              </a:defRPr>
-            </a:pPr>
-            <a:r>
-              <a:t>🏛️ THE WORLD INVARIANT</a:t>
-            </a:r>
-          </a:p>
-          <a:p>
-            <a:pPr>
-              <a:defRPr sz="1000">
+              <a:defRPr sz="1050" b="1">
+                <a:solidFill>
+                  <a:srgbClr val="0284C7"/>
+                </a:solidFill>
+              </a:defRPr>
+            </a:pPr>
+            <a:r>
+              <a:t>🏛️ DERIVED WORLD INVARIANT (TIER 0)</a:t>
+            </a:r>
+          </a:p>
+          <a:p>
+            <a:pPr>
+              <a:defRPr sz="930">
                 <a:solidFill>
                   <a:srgbClr val="0F172A"/>
                 </a:solidFill>
               </a:defRPr>
             </a:pPr>
             <a:r>
-              <a:t>Production Availability Invariant: 99.99% service uptime supersedes manual operator overrides. Automated rollbacks trigger instantly whenever error budgets or lock latency thresholds drain.</a:t>
+              <a:t>Hardware FIDO2 WebAuthn cryptographic keys are mandatory across production VPCs. Legacy SMS OTP and voice telephone MFA are STRICTLY PROHIBITED due to SIM-swapping vulnerabilities.</a:t>
             </a:r>
           </a:p>
           <a:p>
             <a:br/>
             <a:pPr>
-              <a:defRPr sz="1100" b="1">
+              <a:defRPr sz="1050" b="1">
                 <a:solidFill>
                   <a:srgbClr val="0284C7"/>
                 </a:solidFill>
               </a:defRPr>
             </a:pPr>
             <a:r>
-              <a:t>📏 GROUND TRUTH BOUNDS</a:t>
-            </a:r>
-          </a:p>
-          <a:p>
-            <a:pPr>
-              <a:defRPr sz="1000">
+              <a:t>📏 GROUND TRUTH BOUNDS (EXACT LIMITS)</a:t>
+            </a:r>
+          </a:p>
+          <a:p>
+            <a:pPr>
+              <a:defRPr sz="930">
                 <a:solidFill>
                   <a:srgbClr val="0F172A"/>
                 </a:solidFill>
               </a:defRPr>
             </a:pPr>
             <a:r>
-              <a:t>Canary Traffic Proportion: strictly 5% for not less than 15 MINUTES (900s).</a:t>
+              <a:t>Direct database write lease TTL: capped at exactly 4 HOURS (240 minutes).</a:t>
             </a:r>
             <a:br/>
             <a:r>
-              <a:t>Database Migration Metadata Lock: MUST NOT EXCEED 200 MILLISECONDS.</a:t>
+              <a:t>Emergency Break-Glass tokens: hard-capped at exactly 2 HOURS (7,200 seconds).</a:t>
             </a:r>
           </a:p>
           <a:p>
             <a:br/>
             <a:pPr>
-              <a:defRPr sz="1100" b="1">
+              <a:defRPr sz="1050" b="1">
                 <a:solidFill>
                   <a:srgbClr val="EF4444"/>
                 </a:solidFill>
               </a:defRPr>
             </a:pPr>
             <a:r>
-              <a:t>⚡ DAG CIRCUIT BREAKER</a:t>
-            </a:r>
-          </a:p>
-          <a:p>
-            <a:pPr>
-              <a:defRPr sz="1000">
+              <a:t>⚡ EXECUTABLE DAG &amp; CIRCUIT BREAKER</a:t>
+            </a:r>
+          </a:p>
+          <a:p>
+            <a:pPr>
+              <a:defRPr sz="930">
                 <a:solidFill>
                   <a:srgbClr val="0F172A"/>
                 </a:solidFill>
               </a:defRPr>
             </a:pPr>
             <a:r>
-              <a:t>The DAG mounts automated tripwires: if DDL migration metadata lock wait exceeds 200ms or Canary 5xx error rate exceeds 0.05%, it immediately aborts migration and triggers an automated instant rollback.</a:t>
+              <a:t>The DAG intercepts unauthorized escalations: if Break-Glass token expires at 2 hours, it instantly terminates DB leases, reverts credentials, and dispatches an immutable SOC2 audit incident to SIRT.</a:t>
             </a:r>
           </a:p>
         </p:txBody>
       </p:sp>
       <p:pic>
         <p:nvPicPr>
-          <p:cNvPr id="5" name="Picture 4" descr="app8_cloud_devops_flowchart.png"/>
+          <p:cNvPr id="5" name="Picture 4" descr="app8_it_security_flowchart.png"/>
           <p:cNvPicPr>
             <a:picLocks noChangeAspect="1"/>
           </p:cNvPicPr>
@@ -4269,8 +5224,8 @@
         </p:blipFill>
         <p:spPr>
           <a:xfrm>
-            <a:off x="5303520" y="1463040"/>
-            <a:ext cx="6126480" cy="4846320"/>
+            <a:off x="5669280" y="1371600"/>
+            <a:ext cx="5788152" cy="5029200"/>
           </a:xfrm>
           <a:prstGeom prst="rect">
             <a:avLst/>
@@ -4311,8 +5266,8 @@
         </p:nvSpPr>
         <p:spPr>
           <a:xfrm>
-            <a:off x="731520" y="365760"/>
-            <a:ext cx="7315200" cy="320040"/>
+            <a:off x="731520" y="320040"/>
+            <a:ext cx="7315200" cy="292608"/>
           </a:xfrm>
           <a:prstGeom prst="rect">
             <a:avLst/>
@@ -4333,7 +5288,7 @@
               </a:defRPr>
             </a:pPr>
             <a:r>
-              <a:t>📘 EXAMPLE 04: NARRATIVE PHYSICS &amp; FOLKLORE MODELING</a:t>
+              <a:t>📘 EXAMPLE 02 (PART 1): FINANCIAL CRIME &amp; REGULATION — ORIGINAL INPUT INTAKE</a:t>
             </a:r>
           </a:p>
         </p:txBody>
@@ -4346,8 +5301,8 @@
         </p:nvSpPr>
         <p:spPr>
           <a:xfrm>
-            <a:off x="731520" y="640080"/>
-            <a:ext cx="10058400" cy="594360"/>
+            <a:off x="731520" y="594360"/>
+            <a:ext cx="10515600" cy="502920"/>
           </a:xfrm>
           <a:prstGeom prst="rect">
             <a:avLst/>
@@ -4361,14 +5316,14 @@
           <a:lstStyle/>
           <a:p>
             <a:pPr>
-              <a:defRPr sz="2200" b="1">
+              <a:defRPr sz="2100" b="1">
                 <a:solidFill>
                   <a:srgbClr val="0F172A"/>
                 </a:solidFill>
               </a:defRPr>
             </a:pPr>
             <a:r>
-              <a:t>Literature &amp; Narrative: Story Invariants &amp; The Hero's Journey</a:t>
+              <a:t>FinTech AML Dispute: Original Ingestion &amp; Policy Document</a:t>
             </a:r>
           </a:p>
         </p:txBody>
@@ -4381,8 +5336,8 @@
         </p:nvSpPr>
         <p:spPr>
           <a:xfrm>
-            <a:off x="731520" y="1463040"/>
-            <a:ext cx="4389120" cy="4846320"/>
+            <a:off x="731520" y="1371600"/>
+            <a:ext cx="4754880" cy="5029200"/>
           </a:xfrm>
           <a:prstGeom prst="roundRect">
             <a:avLst/>
@@ -4415,91 +5370,103 @@
           <a:lstStyle/>
           <a:p>
             <a:pPr algn="ctr">
-              <a:defRPr sz="1100" b="1">
-                <a:solidFill>
-                  <a:srgbClr val="8B5CF6"/>
-                </a:solidFill>
-              </a:defRPr>
-            </a:pPr>
-            <a:r>
-              <a:t>🏛️ THE WORLD INVARIANT</a:t>
-            </a:r>
-          </a:p>
-          <a:p>
-            <a:pPr>
-              <a:defRPr sz="1000">
+              <a:defRPr sz="1050" b="1">
+                <a:solidFill>
+                  <a:srgbClr val="10B981"/>
+                </a:solidFill>
+              </a:defRPr>
+            </a:pPr>
+            <a:r>
+              <a:t>📥 INPUT 1: RAW SOURCE DOCUMENT / SOP</a:t>
+            </a:r>
+          </a:p>
+          <a:p>
+            <a:pPr>
+              <a:defRPr sz="950" b="1">
                 <a:solidFill>
                   <a:srgbClr val="0F172A"/>
                 </a:solidFill>
               </a:defRPr>
             </a:pPr>
             <a:r>
-              <a:t>World Invariant: Fruitless Mountain is completely barren; nothing grows on it and birds/animals do not rest there. The mud village land is stubbornly poor. Minli has an impulsive, quick-acting nature.</a:t>
-            </a:r>
-          </a:p>
-          <a:p>
+              <a:t>Title: POL-OPS-AML-2026-015: FinTech Dispute Intake &amp; AML Hold</a:t>
+            </a:r>
+          </a:p>
+          <a:p>
+            <a:pPr>
+              <a:defRPr sz="900" i="1">
+                <a:solidFill>
+                  <a:srgbClr val="334155"/>
+                </a:solidFill>
+              </a:defRPr>
+            </a:pPr>
+            <a:r>
+              <a:t>"§ 1.0 Tier-1 Instant Provisional Refund Guidelines: Cardholder disputes for unauthorized transactions with an aggregate claim amount EQUAL TO OR LESS THAN $150.00 and a machine risk score under 25 may be provisionally credited within 60 seconds without supervisor override.</a:t>
+            </a:r>
             <a:br/>
-            <a:pPr>
-              <a:defRPr sz="1100" b="1">
+            <a:r>
+              <a:t>§ 2.0 AML Velocity &amp; SAR Filing Mandatory Freeze: Automated rule processors detecting transaction velocities exceeding $5,000.00 within a 24-hour window on newly provisioned cards MUST IMMEDIATELY PLACE A 72-HOUR RESTRICTIVE HOLD. Under Federal Non-Tipping Invariants (31 U.S.C. § 5318(g)), agents and customer support are STRICTLY PROHIBITED from disclosing SAR investigations.</a:t>
+            </a:r>
+            <a:br/>
+            <a:r>
+              <a:t>§ 3.0 Merchant Evidence: Merchants have strictly 5 business days to submit signed carrier proof of delivery."</a:t>
+            </a:r>
+          </a:p>
+          <a:p>
+            <a:br/>
+            <a:pPr>
+              <a:defRPr sz="1050" b="1">
                 <a:solidFill>
                   <a:srgbClr val="0284C7"/>
                 </a:solidFill>
               </a:defRPr>
             </a:pPr>
             <a:r>
-              <a:t>📏 GROUND TRUTH BOUNDS</a:t>
-            </a:r>
-          </a:p>
-          <a:p>
-            <a:pPr>
-              <a:defRPr sz="1000">
+              <a:t>🌐 INPUT 2: WEB ADDRESS / TARGET ENDPOINT</a:t>
+            </a:r>
+          </a:p>
+          <a:p>
+            <a:pPr>
+              <a:defRPr sz="950" b="1">
                 <a:solidFill>
                   <a:srgbClr val="0F172A"/>
                 </a:solidFill>
               </a:defRPr>
             </a:pPr>
             <a:r>
-              <a:t>Exact Family Bounds: only 3 people live in the house (Minli, Father, Mother).</a:t>
-            </a:r>
+              <a:t>URL: https://internal.corp.local/disputes</a:t>
+            </a:r>
+          </a:p>
+          <a:p>
             <a:br/>
-            <a:r>
-              <a:t>House Bound: tiny boards tied with twine.</a:t>
-            </a:r>
-            <a:br/>
-            <a:r>
-              <a:t>Geography: the corner where Fruitless Mountain and Jade River meet.</a:t>
-            </a:r>
-          </a:p>
-          <a:p>
-            <a:br/>
-            <a:pPr>
-              <a:defRPr sz="1100" b="1">
+            <a:pPr>
+              <a:defRPr sz="1050" b="1">
                 <a:solidFill>
                   <a:srgbClr val="EF4444"/>
                 </a:solidFill>
               </a:defRPr>
             </a:pPr>
             <a:r>
-              <a:t>⚡ DAG CIRCUIT BREAKER</a:t>
-            </a:r>
-          </a:p>
-          <a:p>
-            <a:pPr>
-              <a:defRPr sz="1000">
+              <a:t>⚠️ WHY NAIVE LLMS FAIL ON THIS INPUT</a:t>
+            </a:r>
+          </a:p>
+          <a:p>
+            <a:pPr>
+              <a:defRPr sz="919">
                 <a:solidFill>
                   <a:srgbClr val="0F172A"/>
                 </a:solidFill>
               </a:defRPr>
             </a:pPr>
             <a:r>
-              <a:t>Instead of IT jargon ('cryptographic telemetry'), the DAG maps the real dramatic dilemma: Accept Poverty &amp; Stagnate vs. Follow Impulsive Spirit and embark on the quest to find the Old Man of the Moon.</a:t>
+              <a:t>An empathetic chatbot will naturally try to answer a customer's question: 'Why is my money frozen?'. Under 31 U.S.C. § 5318(g), tipping off a customer that an AML/SAR hold is in place is a federal crime punishable by fines and imprisonment!</a:t>
             </a:r>
           </a:p>
         </p:txBody>
       </p:sp>
       <p:pic>
         <p:nvPicPr>
-          <p:cNvPr id="5" name="Picture 4" descr="verified_flowchart_expanded_big.png"/>
+          <p:cNvPr id="5" name="Picture 4" descr="app8_fintech_dispute_step1.png"/>
           <p:cNvPicPr>
             <a:picLocks noChangeAspect="1"/>
           </p:cNvPicPr>
@@ -4513,8 +5480,8 @@
         </p:blipFill>
         <p:spPr>
           <a:xfrm>
-            <a:off x="5303520" y="1463040"/>
-            <a:ext cx="6126480" cy="4846320"/>
+            <a:off x="5669280" y="1371600"/>
+            <a:ext cx="5788152" cy="5029200"/>
           </a:xfrm>
           <a:prstGeom prst="rect">
             <a:avLst/>
@@ -4555,8 +5522,8 @@
         </p:nvSpPr>
         <p:spPr>
           <a:xfrm>
-            <a:off x="731520" y="365760"/>
-            <a:ext cx="7315200" cy="320040"/>
+            <a:off x="731520" y="320040"/>
+            <a:ext cx="7315200" cy="292608"/>
           </a:xfrm>
           <a:prstGeom prst="rect">
             <a:avLst/>
@@ -4577,7 +5544,7 @@
               </a:defRPr>
             </a:pPr>
             <a:r>
-              <a:t>📘 GROUNDTRUTH ARCHITECTURE PRINCIPLES</a:t>
+              <a:t>📘 EXAMPLE 02 (PART 2): FINANCIAL CRIME &amp; REGULATION — GROUND TRUTH OUTPUT &amp; DAG</a:t>
             </a:r>
           </a:p>
         </p:txBody>
@@ -4590,8 +5557,8 @@
         </p:nvSpPr>
         <p:spPr>
           <a:xfrm>
-            <a:off x="731520" y="640080"/>
-            <a:ext cx="10058400" cy="594360"/>
+            <a:off x="731520" y="594360"/>
+            <a:ext cx="10515600" cy="502920"/>
           </a:xfrm>
           <a:prstGeom prst="rect">
             <a:avLst/>
@@ -4605,63 +5572,28 @@
           <a:lstStyle/>
           <a:p>
             <a:pPr>
-              <a:defRPr sz="2200" b="1">
+              <a:defRPr sz="2100" b="1">
                 <a:solidFill>
                   <a:srgbClr val="0F172A"/>
                 </a:solidFill>
               </a:defRPr>
             </a:pPr>
             <a:r>
-              <a:t>The GroundTruth Formula: From Raw Input to Reliable Agent</a:t>
-            </a:r>
-          </a:p>
-        </p:txBody>
-      </p:sp>
-      <p:sp>
-        <p:nvSpPr>
-          <p:cNvPr id="4" name="TextBox 3"/>
-          <p:cNvSpPr txBox="1"/>
-          <p:nvPr/>
-        </p:nvSpPr>
-        <p:spPr>
-          <a:xfrm>
-            <a:off x="731520" y="1188720"/>
-            <a:ext cx="10515600" cy="320040"/>
-          </a:xfrm>
-          <a:prstGeom prst="rect">
-            <a:avLst/>
-          </a:prstGeom>
-          <a:noFill/>
-        </p:spPr>
-        <p:txBody>
-          <a:bodyPr wrap="square">
-            <a:spAutoFit/>
-          </a:bodyPr>
-          <a:lstStyle/>
-          <a:p>
-            <a:pPr>
-              <a:defRPr sz="1100">
-                <a:solidFill>
-                  <a:srgbClr val="64748B"/>
-                </a:solidFill>
-              </a:defRPr>
-            </a:pPr>
-            <a:r>
-              <a:t>How the 5-Tier Policy Tree and DAG Circuit Breakers eliminate hallucination across any domain.</a:t>
-            </a:r>
-          </a:p>
-        </p:txBody>
-      </p:sp>
-      <p:sp>
-        <p:nvSpPr>
-          <p:cNvPr id="5" name="Rounded Rectangle 4"/>
+              <a:t>FinTech AML Dispute: Compiled Ground Truth &amp; Flowchart DAG</a:t>
+            </a:r>
+          </a:p>
+        </p:txBody>
+      </p:sp>
+      <p:sp>
+        <p:nvSpPr>
+          <p:cNvPr id="4" name="Rounded Rectangle 3"/>
           <p:cNvSpPr/>
           <p:nvPr/>
         </p:nvSpPr>
         <p:spPr>
           <a:xfrm>
-            <a:off x="731520" y="1645920"/>
-            <a:ext cx="10728655" cy="4572000"/>
+            <a:off x="731520" y="1371600"/>
+            <a:ext cx="4754880" cy="5029200"/>
           </a:xfrm>
           <a:prstGeom prst="roundRect">
             <a:avLst/>
@@ -4671,7 +5603,7 @@
           </a:solidFill>
           <a:ln w="19050">
             <a:solidFill>
-              <a:srgbClr val="CBD5E1"/>
+              <a:srgbClr val="E2E8F0"/>
             </a:solidFill>
           </a:ln>
         </p:spPr>
@@ -4694,118 +5626,608 @@
           <a:lstStyle/>
           <a:p>
             <a:pPr algn="ctr">
-              <a:defRPr sz="1300" b="1">
+              <a:defRPr sz="1050" b="1">
+                <a:solidFill>
+                  <a:srgbClr val="10B981"/>
+                </a:solidFill>
+              </a:defRPr>
+            </a:pPr>
+            <a:r>
+              <a:t>🏛️ DERIVED WORLD INVARIANT (TIER 0)</a:t>
+            </a:r>
+          </a:p>
+          <a:p>
+            <a:pPr>
+              <a:defRPr sz="930">
+                <a:solidFill>
+                  <a:srgbClr val="0F172A"/>
+                </a:solidFill>
+              </a:defRPr>
+            </a:pPr>
+            <a:r>
+              <a:t>Federal Non-Tipping Invariant (31 U.S.C. § 5318(g)): Agents and customer support are STRICTLY PROHIBITED from tipping off customers about Suspicious Activity Report (SAR) filings or AML freezes.</a:t>
+            </a:r>
+          </a:p>
+          <a:p>
+            <a:br/>
+            <a:pPr>
+              <a:defRPr sz="1050" b="1">
                 <a:solidFill>
                   <a:srgbClr val="0284C7"/>
                 </a:solidFill>
               </a:defRPr>
             </a:pPr>
             <a:r>
-              <a:t>🎯 KEY TAKEAWAYS FOR AI SYSTEMS ARCHITECTS</a:t>
-            </a:r>
-          </a:p>
-          <a:p>
+              <a:t>📏 GROUND TRUTH BOUNDS (EXACT LIMITS)</a:t>
+            </a:r>
+          </a:p>
+          <a:p>
+            <a:pPr>
+              <a:defRPr sz="930">
+                <a:solidFill>
+                  <a:srgbClr val="0F172A"/>
+                </a:solidFill>
+              </a:defRPr>
+            </a:pPr>
+            <a:r>
+              <a:t>Instant Tier-1 Provisional Credit: EQUAL TO OR LESS THAN $150.00.</a:t>
+            </a:r>
             <a:br/>
-            <a:pPr>
-              <a:defRPr sz="1150" b="1">
+            <a:r>
+              <a:t>High-Velocity AML Hold Window: exactly 72 HOURS.</a:t>
+            </a:r>
+            <a:br/>
+            <a:r>
+              <a:t>Merchant Delivery Proof Rebuttal: strictly 5 business days.</a:t>
+            </a:r>
+          </a:p>
+          <a:p>
+            <a:br/>
+            <a:pPr>
+              <a:defRPr sz="1050" b="1">
+                <a:solidFill>
+                  <a:srgbClr val="EF4444"/>
+                </a:solidFill>
+              </a:defRPr>
+            </a:pPr>
+            <a:r>
+              <a:t>⚡ EXECUTABLE DAG &amp; CIRCUIT BREAKER</a:t>
+            </a:r>
+          </a:p>
+          <a:p>
+            <a:pPr>
+              <a:defRPr sz="930">
                 <a:solidFill>
                   <a:srgbClr val="0F172A"/>
                 </a:solidFill>
               </a:defRPr>
             </a:pPr>
             <a:r>
-              <a:t>• 1. True Ground Truth Means No Hallucinated Numbers</a:t>
-            </a:r>
-          </a:p>
-          <a:p>
-            <a:pPr>
-              <a:defRPr sz="1050">
-                <a:solidFill>
-                  <a:srgbClr val="475569"/>
-                </a:solidFill>
-              </a:defRPr>
-            </a:pPr>
-            <a:r>
-              <a:t>   If a source (novel, Wikipedia, whitepaper) doesn't specify physical constants, leave them algebraic. Inventing 42 kPa or $1.5% from thin air is a catastrophic failure of ground truth.</a:t>
-            </a:r>
-          </a:p>
-          <a:p>
+              <a:t>The DAG routes claims &lt; $150 to automated reversal. If 24h card velocity exceeds $5,000, it instantly routes into a 72-hour frozen gate. Missing tracking proof triggers automatic merchant forfeiture.</a:t>
+            </a:r>
+          </a:p>
+        </p:txBody>
+      </p:sp>
+      <p:pic>
+        <p:nvPicPr>
+          <p:cNvPr id="5" name="Picture 4" descr="app8_fintech_dispute_flowchart.png"/>
+          <p:cNvPicPr>
+            <a:picLocks noChangeAspect="1"/>
+          </p:cNvPicPr>
+          <p:nvPr/>
+        </p:nvPicPr>
+        <p:blipFill>
+          <a:blip r:embed="rId2"/>
+          <a:stretch>
+            <a:fillRect/>
+          </a:stretch>
+        </p:blipFill>
+        <p:spPr>
+          <a:xfrm>
+            <a:off x="5669280" y="1371600"/>
+            <a:ext cx="5788152" cy="5029200"/>
+          </a:xfrm>
+          <a:prstGeom prst="rect">
+            <a:avLst/>
+          </a:prstGeom>
+        </p:spPr>
+      </p:pic>
+    </p:spTree>
+  </p:cSld>
+  <p:clrMapOvr>
+    <a:masterClrMapping/>
+  </p:clrMapOvr>
+</p:sld>
+</file>
+
+<file path=ppt/slides/slide8.xml><?xml version="1.0" encoding="utf-8"?>
+<p:sld xmlns:a="http://schemas.openxmlformats.org/drawingml/2006/main" xmlns:p="http://schemas.openxmlformats.org/presentationml/2006/main" xmlns:r="http://schemas.openxmlformats.org/officeDocument/2006/relationships">
+  <p:cSld>
+    <p:bg>
+      <p:bgPr>
+        <a:solidFill>
+          <a:srgbClr val="FFFFFF"/>
+        </a:solidFill>
+        <a:effectLst/>
+      </p:bgPr>
+    </p:bg>
+    <p:spTree>
+      <p:nvGrpSpPr>
+        <p:cNvPr id="1" name=""/>
+        <p:cNvGrpSpPr/>
+        <p:nvPr/>
+      </p:nvGrpSpPr>
+      <p:grpSpPr/>
+      <p:sp>
+        <p:nvSpPr>
+          <p:cNvPr id="2" name="TextBox 1"/>
+          <p:cNvSpPr txBox="1"/>
+          <p:nvPr/>
+        </p:nvSpPr>
+        <p:spPr>
+          <a:xfrm>
+            <a:off x="731520" y="320040"/>
+            <a:ext cx="7315200" cy="292608"/>
+          </a:xfrm>
+          <a:prstGeom prst="rect">
+            <a:avLst/>
+          </a:prstGeom>
+          <a:noFill/>
+        </p:spPr>
+        <p:txBody>
+          <a:bodyPr wrap="square">
+            <a:spAutoFit/>
+          </a:bodyPr>
+          <a:lstStyle/>
+          <a:p>
+            <a:pPr>
+              <a:defRPr sz="1000" b="1">
+                <a:solidFill>
+                  <a:srgbClr val="0284C7"/>
+                </a:solidFill>
+              </a:defRPr>
+            </a:pPr>
+            <a:r>
+              <a:t>📘 EXAMPLE 03 (PART 1): SITE RELIABILITY ENGINEERING (SRE) — ORIGINAL INPUT INTAKE</a:t>
+            </a:r>
+          </a:p>
+        </p:txBody>
+      </p:sp>
+      <p:sp>
+        <p:nvSpPr>
+          <p:cNvPr id="3" name="TextBox 2"/>
+          <p:cNvSpPr txBox="1"/>
+          <p:nvPr/>
+        </p:nvSpPr>
+        <p:spPr>
+          <a:xfrm>
+            <a:off x="731520" y="594360"/>
+            <a:ext cx="10515600" cy="502920"/>
+          </a:xfrm>
+          <a:prstGeom prst="rect">
+            <a:avLst/>
+          </a:prstGeom>
+          <a:noFill/>
+        </p:spPr>
+        <p:txBody>
+          <a:bodyPr wrap="square">
+            <a:spAutoFit/>
+          </a:bodyPr>
+          <a:lstStyle/>
+          <a:p>
+            <a:pPr>
+              <a:defRPr sz="2100" b="1">
+                <a:solidFill>
+                  <a:srgbClr val="0F172A"/>
+                </a:solidFill>
+              </a:defRPr>
+            </a:pPr>
+            <a:r>
+              <a:t>Cloud DevOps: Original Ingestion &amp; SRE Runbook</a:t>
+            </a:r>
+          </a:p>
+        </p:txBody>
+      </p:sp>
+      <p:sp>
+        <p:nvSpPr>
+          <p:cNvPr id="4" name="Rounded Rectangle 3"/>
+          <p:cNvSpPr/>
+          <p:nvPr/>
+        </p:nvSpPr>
+        <p:spPr>
+          <a:xfrm>
+            <a:off x="731520" y="1371600"/>
+            <a:ext cx="4754880" cy="5029200"/>
+          </a:xfrm>
+          <a:prstGeom prst="roundRect">
+            <a:avLst/>
+          </a:prstGeom>
+          <a:solidFill>
+            <a:srgbClr val="F8FAFC"/>
+          </a:solidFill>
+          <a:ln w="19050">
+            <a:solidFill>
+              <a:srgbClr val="E2E8F0"/>
+            </a:solidFill>
+          </a:ln>
+        </p:spPr>
+        <p:style>
+          <a:lnRef idx="1">
+            <a:schemeClr val="accent1"/>
+          </a:lnRef>
+          <a:fillRef idx="3">
+            <a:schemeClr val="accent1"/>
+          </a:fillRef>
+          <a:effectRef idx="2">
+            <a:schemeClr val="accent1"/>
+          </a:effectRef>
+          <a:fontRef idx="minor">
+            <a:schemeClr val="lt1"/>
+          </a:fontRef>
+        </p:style>
+        <p:txBody>
+          <a:bodyPr rtlCol="0" anchor="ctr" wrap="square"/>
+          <a:lstStyle/>
+          <a:p>
+            <a:pPr algn="ctr">
+              <a:defRPr sz="1050" b="1">
+                <a:solidFill>
+                  <a:srgbClr val="F59E0B"/>
+                </a:solidFill>
+              </a:defRPr>
+            </a:pPr>
+            <a:r>
+              <a:t>📥 INPUT 1: RAW SOURCE DOCUMENT / SOP</a:t>
+            </a:r>
+          </a:p>
+          <a:p>
+            <a:pPr>
+              <a:defRPr sz="950" b="1">
+                <a:solidFill>
+                  <a:srgbClr val="0F172A"/>
+                </a:solidFill>
+              </a:defRPr>
+            </a:pPr>
+            <a:r>
+              <a:t>Title: SRE-RUN-DB-MIG-2026: Cloud Canary Release &amp; DB Lock Runbook</a:t>
+            </a:r>
+          </a:p>
+          <a:p>
+            <a:pPr>
+              <a:defRPr sz="900" i="1">
+                <a:solidFill>
+                  <a:srgbClr val="334155"/>
+                </a:solidFill>
+              </a:defRPr>
+            </a:pPr>
+            <a:r>
+              <a:t>"§ 1.0 Production Canary Deployment Gate: New microservice artifact builds MUST FIRST route strictly 5% of live production traffic to isolated canary container pods. Canary evaluation duration MUST NOT BE LESS THAN 15 MINUTES (900 seconds) prior to promotion.</a:t>
+            </a:r>
             <a:br/>
-            <a:pPr>
-              <a:defRPr sz="1150" b="1">
+            <a:r>
+              <a:t>§ 2.0 Database Schema Lock Mitigation: DDL migrations (ALTER TABLE, CREATE INDEX) executing against primary transactional relational tables MUST ACQUIRE EXCLUSIVE METADATA LOCKS IN LESS THAN 200 MILLISECONDS. If lock acquisition exceeds 200ms, the migration script MUST IMMEDIATELY ABORT and yield lock queues.</a:t>
+            </a:r>
+            <a:br/>
+            <a:r>
+              <a:t>§ 3.0 Automated SRE Rollback Tripwires: If Canary 5xx HTTP error rates exceed 0.05% or P99 request latency degrades by &gt; 20%, automated deployment orchestrators MUST TRIGGER AN INSTANT ROLLBACK."</a:t>
+            </a:r>
+          </a:p>
+          <a:p>
+            <a:br/>
+            <a:pPr>
+              <a:defRPr sz="1050" b="1">
+                <a:solidFill>
+                  <a:srgbClr val="0284C7"/>
+                </a:solidFill>
+              </a:defRPr>
+            </a:pPr>
+            <a:r>
+              <a:t>🌐 INPUT 2: WEB ADDRESS / TARGET ENDPOINT</a:t>
+            </a:r>
+          </a:p>
+          <a:p>
+            <a:pPr>
+              <a:defRPr sz="950" b="1">
                 <a:solidFill>
                   <a:srgbClr val="0F172A"/>
                 </a:solidFill>
               </a:defRPr>
             </a:pPr>
             <a:r>
-              <a:t>• 2. World Invariants Govern the Reality of the Environment</a:t>
-            </a:r>
-          </a:p>
-          <a:p>
-            <a:pPr>
-              <a:defRPr sz="1050">
-                <a:solidFill>
-                  <a:srgbClr val="475569"/>
-                </a:solidFill>
-              </a:defRPr>
-            </a:pPr>
-            <a:r>
-              <a:t>   Whether it's the physics of Fruitless Mountain, SOC2 4-hour lease timers, or mass-conservation laws, world invariants never bend to an LLM's prompt persuasion.</a:t>
+              <a:t>URL: https://internal.corp.local/release-console</a:t>
             </a:r>
           </a:p>
           <a:p>
             <a:br/>
             <a:pPr>
-              <a:defRPr sz="1150" b="1">
+              <a:defRPr sz="1050" b="1">
+                <a:solidFill>
+                  <a:srgbClr val="EF4444"/>
+                </a:solidFill>
+              </a:defRPr>
+            </a:pPr>
+            <a:r>
+              <a:t>⚠️ WHY NAIVE LLMS FAIL ON THIS INPUT</a:t>
+            </a:r>
+          </a:p>
+          <a:p>
+            <a:pPr>
+              <a:defRPr sz="919">
                 <a:solidFill>
                   <a:srgbClr val="0F172A"/>
                 </a:solidFill>
               </a:defRPr>
             </a:pPr>
             <a:r>
-              <a:t>• 3. The 5-Tier Policy Hierarchy Bridges Any Domain</a:t>
-            </a:r>
-          </a:p>
-          <a:p>
-            <a:pPr>
-              <a:defRPr sz="1050">
-                <a:solidFill>
-                  <a:srgbClr val="475569"/>
-                </a:solidFill>
-              </a:defRPr>
-            </a:pPr>
-            <a:r>
-              <a:t>   Root Invariants ➔ Scoped Directives ➔ Execution Rules ➔ Parameter Bounds ➔ Dead Ends provides a universal contract layer for both engineering runbooks and story plots.</a:t>
+              <a:t>During an outage or high-load migration, an LLM might decide to 'retry for 10 seconds' to let the DDL lock acquire. In high-throughput PostgreSQL/Aurora clusters, a 10s metadata lock queues thousands of transactions, cascading into site-wide connection pool collapse.</a:t>
+            </a:r>
+          </a:p>
+        </p:txBody>
+      </p:sp>
+      <p:pic>
+        <p:nvPicPr>
+          <p:cNvPr id="5" name="Picture 4" descr="app8_cloud_devops_step1.png"/>
+          <p:cNvPicPr>
+            <a:picLocks noChangeAspect="1"/>
+          </p:cNvPicPr>
+          <p:nvPr/>
+        </p:nvPicPr>
+        <p:blipFill>
+          <a:blip r:embed="rId2"/>
+          <a:stretch>
+            <a:fillRect/>
+          </a:stretch>
+        </p:blipFill>
+        <p:spPr>
+          <a:xfrm>
+            <a:off x="5669280" y="1371600"/>
+            <a:ext cx="5788152" cy="5029200"/>
+          </a:xfrm>
+          <a:prstGeom prst="rect">
+            <a:avLst/>
+          </a:prstGeom>
+        </p:spPr>
+      </p:pic>
+    </p:spTree>
+  </p:cSld>
+  <p:clrMapOvr>
+    <a:masterClrMapping/>
+  </p:clrMapOvr>
+</p:sld>
+</file>
+
+<file path=ppt/slides/slide9.xml><?xml version="1.0" encoding="utf-8"?>
+<p:sld xmlns:a="http://schemas.openxmlformats.org/drawingml/2006/main" xmlns:p="http://schemas.openxmlformats.org/presentationml/2006/main" xmlns:r="http://schemas.openxmlformats.org/officeDocument/2006/relationships">
+  <p:cSld>
+    <p:bg>
+      <p:bgPr>
+        <a:solidFill>
+          <a:srgbClr val="FFFFFF"/>
+        </a:solidFill>
+        <a:effectLst/>
+      </p:bgPr>
+    </p:bg>
+    <p:spTree>
+      <p:nvGrpSpPr>
+        <p:cNvPr id="1" name=""/>
+        <p:cNvGrpSpPr/>
+        <p:nvPr/>
+      </p:nvGrpSpPr>
+      <p:grpSpPr/>
+      <p:sp>
+        <p:nvSpPr>
+          <p:cNvPr id="2" name="TextBox 1"/>
+          <p:cNvSpPr txBox="1"/>
+          <p:nvPr/>
+        </p:nvSpPr>
+        <p:spPr>
+          <a:xfrm>
+            <a:off x="731520" y="320040"/>
+            <a:ext cx="7315200" cy="292608"/>
+          </a:xfrm>
+          <a:prstGeom prst="rect">
+            <a:avLst/>
+          </a:prstGeom>
+          <a:noFill/>
+        </p:spPr>
+        <p:txBody>
+          <a:bodyPr wrap="square">
+            <a:spAutoFit/>
+          </a:bodyPr>
+          <a:lstStyle/>
+          <a:p>
+            <a:pPr>
+              <a:defRPr sz="1000" b="1">
+                <a:solidFill>
+                  <a:srgbClr val="0284C7"/>
+                </a:solidFill>
+              </a:defRPr>
+            </a:pPr>
+            <a:r>
+              <a:t>📘 EXAMPLE 03 (PART 2): SITE RELIABILITY ENGINEERING (SRE) — GROUND TRUTH OUTPUT &amp; DAG</a:t>
+            </a:r>
+          </a:p>
+        </p:txBody>
+      </p:sp>
+      <p:sp>
+        <p:nvSpPr>
+          <p:cNvPr id="3" name="TextBox 2"/>
+          <p:cNvSpPr txBox="1"/>
+          <p:nvPr/>
+        </p:nvSpPr>
+        <p:spPr>
+          <a:xfrm>
+            <a:off x="731520" y="594360"/>
+            <a:ext cx="10515600" cy="502920"/>
+          </a:xfrm>
+          <a:prstGeom prst="rect">
+            <a:avLst/>
+          </a:prstGeom>
+          <a:noFill/>
+        </p:spPr>
+        <p:txBody>
+          <a:bodyPr wrap="square">
+            <a:spAutoFit/>
+          </a:bodyPr>
+          <a:lstStyle/>
+          <a:p>
+            <a:pPr>
+              <a:defRPr sz="2100" b="1">
+                <a:solidFill>
+                  <a:srgbClr val="0F172A"/>
+                </a:solidFill>
+              </a:defRPr>
+            </a:pPr>
+            <a:r>
+              <a:t>Cloud DevOps: Compiled Ground Truth &amp; Flowchart DAG</a:t>
+            </a:r>
+          </a:p>
+        </p:txBody>
+      </p:sp>
+      <p:sp>
+        <p:nvSpPr>
+          <p:cNvPr id="4" name="Rounded Rectangle 3"/>
+          <p:cNvSpPr/>
+          <p:nvPr/>
+        </p:nvSpPr>
+        <p:spPr>
+          <a:xfrm>
+            <a:off x="731520" y="1371600"/>
+            <a:ext cx="4754880" cy="5029200"/>
+          </a:xfrm>
+          <a:prstGeom prst="roundRect">
+            <a:avLst/>
+          </a:prstGeom>
+          <a:solidFill>
+            <a:srgbClr val="F8FAFC"/>
+          </a:solidFill>
+          <a:ln w="19050">
+            <a:solidFill>
+              <a:srgbClr val="E2E8F0"/>
+            </a:solidFill>
+          </a:ln>
+        </p:spPr>
+        <p:style>
+          <a:lnRef idx="1">
+            <a:schemeClr val="accent1"/>
+          </a:lnRef>
+          <a:fillRef idx="3">
+            <a:schemeClr val="accent1"/>
+          </a:fillRef>
+          <a:effectRef idx="2">
+            <a:schemeClr val="accent1"/>
+          </a:effectRef>
+          <a:fontRef idx="minor">
+            <a:schemeClr val="lt1"/>
+          </a:fontRef>
+        </p:style>
+        <p:txBody>
+          <a:bodyPr rtlCol="0" anchor="ctr" wrap="square"/>
+          <a:lstStyle/>
+          <a:p>
+            <a:pPr algn="ctr">
+              <a:defRPr sz="1050" b="1">
+                <a:solidFill>
+                  <a:srgbClr val="F59E0B"/>
+                </a:solidFill>
+              </a:defRPr>
+            </a:pPr>
+            <a:r>
+              <a:t>🏛️ DERIVED WORLD INVARIANT (TIER 0)</a:t>
+            </a:r>
+          </a:p>
+          <a:p>
+            <a:pPr>
+              <a:defRPr sz="930">
+                <a:solidFill>
+                  <a:srgbClr val="0F172A"/>
+                </a:solidFill>
+              </a:defRPr>
+            </a:pPr>
+            <a:r>
+              <a:t>Production Availability Invariant: 99.99% service uptime supersedes manual operator overrides. Automated rollbacks trigger instantly whenever error budgets or lock latency thresholds drain.</a:t>
             </a:r>
           </a:p>
           <a:p>
             <a:br/>
             <a:pPr>
-              <a:defRPr sz="1150" b="1">
+              <a:defRPr sz="1050" b="1">
+                <a:solidFill>
+                  <a:srgbClr val="0284C7"/>
+                </a:solidFill>
+              </a:defRPr>
+            </a:pPr>
+            <a:r>
+              <a:t>📏 GROUND TRUTH BOUNDS (EXACT LIMITS)</a:t>
+            </a:r>
+          </a:p>
+          <a:p>
+            <a:pPr>
+              <a:defRPr sz="930">
                 <a:solidFill>
                   <a:srgbClr val="0F172A"/>
                 </a:solidFill>
               </a:defRPr>
             </a:pPr>
             <a:r>
-              <a:t>• 4. Circuit-Breaker DAGs Enforce Deterministic Safety</a:t>
-            </a:r>
-          </a:p>
-          <a:p>
-            <a:pPr>
-              <a:defRPr sz="1050">
-                <a:solidFill>
-                  <a:srgbClr val="475569"/>
-                </a:solidFill>
-              </a:defRPr>
-            </a:pPr>
-            <a:r>
-              <a:t>   By compiling invariants directly into LangGraph decision nodes and tripwire terminals, agents are evaluated and constrained by a deterministic hidden answer key.</a:t>
-            </a:r>
-          </a:p>
-        </p:txBody>
-      </p:sp>
+              <a:t>Canary Traffic Proportion: strictly 5% for not less than 15 MINUTES (900s).</a:t>
+            </a:r>
+            <a:br/>
+            <a:r>
+              <a:t>Database Migration Metadata Lock: MUST NOT EXCEED 200 MILLISECONDS.</a:t>
+            </a:r>
+          </a:p>
+          <a:p>
+            <a:br/>
+            <a:pPr>
+              <a:defRPr sz="1050" b="1">
+                <a:solidFill>
+                  <a:srgbClr val="EF4444"/>
+                </a:solidFill>
+              </a:defRPr>
+            </a:pPr>
+            <a:r>
+              <a:t>⚡ EXECUTABLE DAG &amp; CIRCUIT BREAKER</a:t>
+            </a:r>
+          </a:p>
+          <a:p>
+            <a:pPr>
+              <a:defRPr sz="930">
+                <a:solidFill>
+                  <a:srgbClr val="0F172A"/>
+                </a:solidFill>
+              </a:defRPr>
+            </a:pPr>
+            <a:r>
+              <a:t>The DAG mounts automated tripwires: if DDL migration metadata lock wait exceeds 200ms or Canary 5xx error rate exceeds 0.05%, it immediately aborts migration and triggers an automated instant rollback.</a:t>
+            </a:r>
+          </a:p>
+        </p:txBody>
+      </p:sp>
+      <p:pic>
+        <p:nvPicPr>
+          <p:cNvPr id="5" name="Picture 4" descr="app8_cloud_devops_flowchart.png"/>
+          <p:cNvPicPr>
+            <a:picLocks noChangeAspect="1"/>
+          </p:cNvPicPr>
+          <p:nvPr/>
+        </p:nvPicPr>
+        <p:blipFill>
+          <a:blip r:embed="rId2"/>
+          <a:stretch>
+            <a:fillRect/>
+          </a:stretch>
+        </p:blipFill>
+        <p:spPr>
+          <a:xfrm>
+            <a:off x="5669280" y="1371600"/>
+            <a:ext cx="5788152" cy="5029200"/>
+          </a:xfrm>
+          <a:prstGeom prst="rect">
+            <a:avLst/>
+          </a:prstGeom>
+        </p:spPr>
+      </p:pic>
     </p:spTree>
   </p:cSld>
   <p:clrMapOvr>

</xml_diff>